<commit_message>
BUS-629: add Appendix C — Accounting Standards & GAAP Conversion to project deck
Four new slides (52–55) appended to BUS629_AI_Ratios_Project.pptx:
- Appendix C divider slide
- Why Accounting Standards Matter (five high-impact areas checklist)
- What You Need to Do (four-step workflow with GAAP Bridge tab)
- Resources & Where to Find Them (quick-ref, template, decision memo)

Matches existing deck style: UH green header bar, Open Sans, checklist
boxes, two-column layout with deliverables + checklist panel.

Co-Authored-By: Claude Opus 4.7 (1M context) <noreply@anthropic.com>
</commit_message>
<xml_diff>
--- a/courses/BUS-629-VEMBA-International-Corporate-Finance/BUS629_AI_Ratios_Project.pptx
+++ b/courses/BUS-629-VEMBA-International-Corporate-Finance/BUS629_AI_Ratios_Project.pptx
@@ -59,6 +59,10 @@
     <p:sldId id="353" r:id="rId50"/>
     <p:sldId id="355" r:id="rId51"/>
     <p:sldId id="354" r:id="rId52"/>
+    <p:sldId id="356" r:id="rId58"/>
+    <p:sldId id="357" r:id="rId59"/>
+    <p:sldId id="358" r:id="rId60"/>
+    <p:sldId id="359" r:id="rId61"/>
   </p:sldIdLst>
   <p:sldSz cx="9144000" cy="5143500" type="screen16x9"/>
   <p:notesSz cx="5143500" cy="9144000"/>
@@ -18256,7 +18260,7 @@
                 <a:ea typeface="Open Sans" pitchFamily="34" charset="-122"/>
                 <a:cs typeface="Open Sans" pitchFamily="34" charset="-120"/>
               </a:rPr>
-              <a:t>    saved to models/builds/</a:t>
+              <a:t xml:space="preserve">    saved to models/builds/</a:t>
             </a:r>
             <a:endParaRPr lang="en-US" sz="1100" dirty="0"/>
           </a:p>
@@ -18339,7 +18343,7 @@
                 <a:ea typeface="Open Sans" pitchFamily="34" charset="-122"/>
                 <a:cs typeface="Open Sans" pitchFamily="34" charset="-120"/>
               </a:rPr>
-              <a:t>    source URL, standard, currency, FYE</a:t>
+              <a:t xml:space="preserve">    source URL, standard, currency, FYE</a:t>
             </a:r>
             <a:endParaRPr lang="en-US" sz="1100" dirty="0"/>
           </a:p>
@@ -18943,7 +18947,7 @@
                 <a:ea typeface="Open Sans" pitchFamily="34" charset="-122"/>
                 <a:cs typeface="Open Sans" pitchFamily="34" charset="-120"/>
               </a:rPr>
-              <a:t>This stage builds the foundation for the Financial Statement analysis you will perform in </a:t>
+              <a:t xml:space="preserve">This stage builds the foundation for the Financial Statement analysis you will perform in </a:t>
             </a:r>
             <a:r>
               <a:rPr lang="en-US" sz="1000">
@@ -20322,7 +20326,7 @@
                 <a:ea typeface="Open Sans" pitchFamily="34" charset="-122"/>
                 <a:cs typeface="Open Sans" pitchFamily="34" charset="-120"/>
               </a:rPr>
-              <a:t>Ratio </a:t>
+              <a:t xml:space="preserve">Ratio </a:t>
             </a:r>
             <a:r>
               <a:rPr lang="en-US" sz="4000" b="1">
@@ -25889,7 +25893,7 @@
                 <a:ea typeface="Open Sans" pitchFamily="34" charset="-122"/>
                 <a:cs typeface="Open Sans" pitchFamily="34" charset="-120"/>
               </a:rPr>
-              <a:t>  — Instructor</a:t>
+              <a:t xml:space="preserve">  — Instructor</a:t>
             </a:r>
             <a:endParaRPr lang="en-US" sz="1000" dirty="0"/>
           </a:p>
@@ -43959,6 +43963,3201 @@
 </p:sld>
 </file>
 
+<file path=ppt/slides/slide52.xml><?xml version="1.0" encoding="utf-8"?>
+<p:sld xmlns:a="http://schemas.openxmlformats.org/drawingml/2006/main" xmlns:r="http://schemas.openxmlformats.org/officeDocument/2006/relationships" xmlns:p="http://schemas.openxmlformats.org/presentationml/2006/main">
+  <p:cSld>
+    <p:spTree>
+      <p:nvGrpSpPr>
+        <p:cNvPr id="1" name="">
+          <a:extLst>
+            <a:ext uri="{FF2B5EF4-FFF2-40B4-BE49-F238E27FC236}">
+              <a16:creationId xmlns:a16="http://schemas.microsoft.com/office/drawing/2014/main" id="{86D8C8A8-8564-943A-0CE2-B9EAD893FFB0}"/>
+            </a:ext>
+          </a:extLst>
+        </p:cNvPr>
+        <p:cNvGrpSpPr/>
+        <p:nvPr/>
+      </p:nvGrpSpPr>
+      <p:grpSpPr>
+        <a:xfrm>
+          <a:off x="0" y="0"/>
+          <a:ext cx="0" cy="0"/>
+          <a:chOff x="0" y="0"/>
+          <a:chExt cx="0" cy="0"/>
+        </a:xfrm>
+      </p:grpSpPr>
+      <p:sp>
+        <p:nvSpPr>
+          <p:cNvPr id="2" name="Shape 0">
+            <a:extLst>
+              <a:ext uri="{FF2B5EF4-FFF2-40B4-BE49-F238E27FC236}">
+                <a16:creationId xmlns:a16="http://schemas.microsoft.com/office/drawing/2014/main" id="{0053C377-5E53-F9E8-A27F-0C516CF4EE5A}"/>
+              </a:ext>
+            </a:extLst>
+          </p:cNvPr>
+          <p:cNvSpPr/>
+          <p:nvPr/>
+        </p:nvSpPr>
+        <p:spPr>
+          <a:xfrm>
+            <a:off x="0" y="0"/>
+            <a:ext cx="9144000" cy="36576"/>
+          </a:xfrm>
+          <a:prstGeom prst="rect">
+            <a:avLst/>
+          </a:prstGeom>
+          <a:solidFill>
+            <a:srgbClr val="B8975C"/>
+          </a:solidFill>
+          <a:ln/>
+        </p:spPr>
+        <p:txBody>
+          <a:bodyPr/>
+          <a:lstStyle/>
+          <a:p>
+            <a:endParaRPr lang="en-US"/>
+          </a:p>
+        </p:txBody>
+      </p:sp>
+      <p:sp>
+        <p:nvSpPr>
+          <p:cNvPr id="3" name="Text 1">
+            <a:extLst>
+              <a:ext uri="{FF2B5EF4-FFF2-40B4-BE49-F238E27FC236}">
+                <a16:creationId xmlns:a16="http://schemas.microsoft.com/office/drawing/2014/main" id="{FB49E700-5A07-CB8D-CD15-D0780F2BA747}"/>
+              </a:ext>
+            </a:extLst>
+          </p:cNvPr>
+          <p:cNvSpPr/>
+          <p:nvPr/>
+        </p:nvSpPr>
+        <p:spPr>
+          <a:xfrm>
+            <a:off x="731520" y="548640"/>
+            <a:ext cx="7680960" cy="365760"/>
+          </a:xfrm>
+          <a:prstGeom prst="rect">
+            <a:avLst/>
+          </a:prstGeom>
+          <a:noFill/>
+          <a:ln/>
+        </p:spPr>
+        <p:txBody>
+          <a:bodyPr wrap="square" lIns="0" tIns="0" rIns="0" bIns="0" rtlCol="0" anchor="ctr"/>
+          <a:lstStyle/>
+          <a:p>
+            <a:pPr marL="0" indent="0">
+              <a:buNone/>
+            </a:pPr>
+            <a:r>
+              <a:rPr lang="en-US" sz="1400" b="1" kern="0" spc="600" dirty="0">
+                <a:solidFill>
+                  <a:srgbClr val="B8975C"/>
+                </a:solidFill>
+                <a:latin typeface="Open Sans" pitchFamily="34" charset="0"/>
+                <a:ea typeface="Open Sans" pitchFamily="34" charset="-122"/>
+                <a:cs typeface="Open Sans" pitchFamily="34" charset="-120"/>
+              </a:rPr>
+              <a:t>APPENDIX C</a:t>
+            </a:r>
+            <a:endParaRPr lang="en-US" sz="1400" dirty="0"/>
+          </a:p>
+        </p:txBody>
+      </p:sp>
+      <p:sp>
+        <p:nvSpPr>
+          <p:cNvPr id="4" name="Text 2">
+            <a:extLst>
+              <a:ext uri="{FF2B5EF4-FFF2-40B4-BE49-F238E27FC236}">
+                <a16:creationId xmlns:a16="http://schemas.microsoft.com/office/drawing/2014/main" id="{F54F229D-F05E-B476-5B3E-4BBC55431E5F}"/>
+              </a:ext>
+            </a:extLst>
+          </p:cNvPr>
+          <p:cNvSpPr/>
+          <p:nvPr/>
+        </p:nvSpPr>
+        <p:spPr>
+          <a:xfrm>
+            <a:off x="731520" y="1097280"/>
+            <a:ext cx="7680960" cy="1828800"/>
+          </a:xfrm>
+          <a:prstGeom prst="rect">
+            <a:avLst/>
+          </a:prstGeom>
+          <a:noFill/>
+          <a:ln/>
+        </p:spPr>
+        <p:txBody>
+          <a:bodyPr wrap="square" lIns="0" tIns="0" rIns="0" bIns="0" rtlCol="0" anchor="ctr"/>
+          <a:lstStyle/>
+          <a:p>
+            <a:pPr marL="0" indent="0">
+              <a:lnSpc>
+                <a:spcPct val="110000"/>
+              </a:lnSpc>
+              <a:buNone/>
+            </a:pPr>
+            <a:r>
+              <a:rPr lang="en-US" sz="4000" b="1" dirty="0">
+                <a:solidFill>
+                  <a:schemeClr val="accent6">
+                    <a:lumMod val="50000"/>
+                  </a:schemeClr>
+                </a:solidFill>
+                <a:latin typeface="Open Sans" pitchFamily="34" charset="0"/>
+                <a:ea typeface="Open Sans" pitchFamily="34" charset="-122"/>
+                <a:cs typeface="Open Sans" pitchFamily="34" charset="-120"/>
+              </a:rPr>
+              <a:t>Accounting Standards</a:t>
+            </a:r>
+            <a:endParaRPr lang="en-US" sz="4000" dirty="0">
+              <a:solidFill>
+                <a:schemeClr val="accent6">
+                  <a:lumMod val="50000"/>
+                </a:schemeClr>
+              </a:solidFill>
+            </a:endParaRPr>
+          </a:p>
+          <a:p>
+            <a:pPr marL="0" indent="0">
+              <a:lnSpc>
+                <a:spcPct val="110000"/>
+              </a:lnSpc>
+              <a:buNone/>
+            </a:pPr>
+            <a:r>
+              <a:rPr lang="en-US" sz="4000" b="1" dirty="0">
+                <a:solidFill>
+                  <a:schemeClr val="accent6">
+                    <a:lumMod val="50000"/>
+                  </a:schemeClr>
+                </a:solidFill>
+                <a:latin typeface="Open Sans" pitchFamily="34" charset="0"/>
+                <a:ea typeface="Open Sans" pitchFamily="34" charset="-122"/>
+                <a:cs typeface="Open Sans" pitchFamily="34" charset="-120"/>
+              </a:rPr>
+              <a:t>&amp; GAAP Conversion</a:t>
+            </a:r>
+            <a:endParaRPr lang="en-US" sz="4000" dirty="0">
+              <a:solidFill>
+                <a:schemeClr val="accent6">
+                  <a:lumMod val="50000"/>
+                </a:schemeClr>
+              </a:solidFill>
+            </a:endParaRPr>
+          </a:p>
+        </p:txBody>
+      </p:sp>
+      <p:sp>
+        <p:nvSpPr>
+          <p:cNvPr id="5" name="Shape 3">
+            <a:extLst>
+              <a:ext uri="{FF2B5EF4-FFF2-40B4-BE49-F238E27FC236}">
+                <a16:creationId xmlns:a16="http://schemas.microsoft.com/office/drawing/2014/main" id="{839A0219-6F48-03FD-88BB-49FB29159640}"/>
+              </a:ext>
+            </a:extLst>
+          </p:cNvPr>
+          <p:cNvSpPr/>
+          <p:nvPr/>
+        </p:nvSpPr>
+        <p:spPr>
+          <a:xfrm>
+            <a:off x="731520" y="3108960"/>
+            <a:ext cx="1828800" cy="36576"/>
+          </a:xfrm>
+          <a:prstGeom prst="rect">
+            <a:avLst/>
+          </a:prstGeom>
+          <a:solidFill>
+            <a:srgbClr val="B8975C"/>
+          </a:solidFill>
+          <a:ln/>
+        </p:spPr>
+        <p:txBody>
+          <a:bodyPr/>
+          <a:lstStyle/>
+          <a:p>
+            <a:endParaRPr lang="en-US"/>
+          </a:p>
+        </p:txBody>
+      </p:sp>
+      <p:sp>
+        <p:nvSpPr>
+          <p:cNvPr id="6" name="Text 4">
+            <a:extLst>
+              <a:ext uri="{FF2B5EF4-FFF2-40B4-BE49-F238E27FC236}">
+                <a16:creationId xmlns:a16="http://schemas.microsoft.com/office/drawing/2014/main" id="{F2900D6E-9BE4-4C5F-F3CB-86C919186C1A}"/>
+              </a:ext>
+            </a:extLst>
+          </p:cNvPr>
+          <p:cNvSpPr/>
+          <p:nvPr/>
+        </p:nvSpPr>
+        <p:spPr>
+          <a:xfrm>
+            <a:off x="731520" y="3337560"/>
+            <a:ext cx="6400800" cy="731520"/>
+          </a:xfrm>
+          <a:prstGeom prst="rect">
+            <a:avLst/>
+          </a:prstGeom>
+          <a:noFill/>
+          <a:ln/>
+        </p:spPr>
+        <p:txBody>
+          <a:bodyPr wrap="square" lIns="0" tIns="0" rIns="0" bIns="0" rtlCol="0" anchor="ctr"/>
+          <a:lstStyle/>
+          <a:p>
+            <a:pPr marL="0" indent="0">
+              <a:lnSpc>
+                <a:spcPct val="140000"/>
+              </a:lnSpc>
+              <a:buNone/>
+            </a:pPr>
+            <a:r>
+              <a:rPr lang="en-US" sz="1400" dirty="0">
+                <a:solidFill>
+                  <a:srgbClr val="8A9BAD"/>
+                </a:solidFill>
+                <a:latin typeface="Open Sans" pitchFamily="34" charset="0"/>
+                <a:ea typeface="Open Sans" pitchFamily="34" charset="-122"/>
+                <a:cs typeface="Open Sans" pitchFamily="34" charset="-120"/>
+              </a:rPr>
+              <a:t>How to handle non-US-GAAP financials when populating your ratios workbook. Covers VAS, IFRS, CAS, JGAAP, and the GAAP Bridge template.</a:t>
+            </a:r>
+            <a:endParaRPr lang="en-US" sz="1400" dirty="0"/>
+          </a:p>
+        </p:txBody>
+      </p:sp>
+      <p:pic>
+        <p:nvPicPr>
+          <p:cNvPr id="7" name="Image 0" descr="preencoded.png">
+            <a:extLst>
+              <a:ext uri="{FF2B5EF4-FFF2-40B4-BE49-F238E27FC236}">
+                <a16:creationId xmlns:a16="http://schemas.microsoft.com/office/drawing/2014/main" id="{C3335FD3-0934-88F3-5290-2F0CA62CFE62}"/>
+              </a:ext>
+            </a:extLst>
+          </p:cNvPr>
+          <p:cNvPicPr>
+            <a:picLocks noChangeAspect="1"/>
+          </p:cNvPicPr>
+          <p:nvPr/>
+        </p:nvPicPr>
+        <p:blipFill>
+          <a:blip r:embed="rId3"/>
+          <a:stretch>
+            <a:fillRect/>
+          </a:stretch>
+        </p:blipFill>
+        <p:spPr>
+          <a:xfrm>
+            <a:off x="7132320" y="3200400"/>
+            <a:ext cx="1097280" cy="1097280"/>
+          </a:xfrm>
+          <a:prstGeom prst="rect">
+            <a:avLst/>
+          </a:prstGeom>
+        </p:spPr>
+      </p:pic>
+      <p:sp>
+        <p:nvSpPr>
+          <p:cNvPr id="8" name="Text 5">
+            <a:extLst>
+              <a:ext uri="{FF2B5EF4-FFF2-40B4-BE49-F238E27FC236}">
+                <a16:creationId xmlns:a16="http://schemas.microsoft.com/office/drawing/2014/main" id="{1E0F0504-7EA9-C4C2-CD3C-A13D947AD528}"/>
+              </a:ext>
+            </a:extLst>
+          </p:cNvPr>
+          <p:cNvSpPr/>
+          <p:nvPr/>
+        </p:nvSpPr>
+        <p:spPr>
+          <a:xfrm>
+            <a:off x="457200" y="4663440"/>
+            <a:ext cx="8229600" cy="320040"/>
+          </a:xfrm>
+          <a:prstGeom prst="rect">
+            <a:avLst/>
+          </a:prstGeom>
+          <a:noFill/>
+          <a:ln/>
+        </p:spPr>
+        <p:txBody>
+          <a:bodyPr wrap="square" lIns="0" tIns="0" rIns="0" bIns="0" rtlCol="0" anchor="ctr"/>
+          <a:lstStyle/>
+          <a:p>
+            <a:pPr marL="0" indent="0" algn="ctr">
+              <a:buNone/>
+            </a:pPr>
+            <a:r>
+              <a:rPr lang="en-US" sz="1000" dirty="0">
+                <a:solidFill>
+                  <a:srgbClr val="5A6B7A"/>
+                </a:solidFill>
+                <a:latin typeface="Open Sans" pitchFamily="34" charset="0"/>
+                <a:ea typeface="Open Sans" pitchFamily="34" charset="-122"/>
+                <a:cs typeface="Open Sans" pitchFamily="34" charset="-120"/>
+              </a:rPr>
+              <a:t>Shidler College of Business  |  University of Hawaiʻi at Mānoa</a:t>
+            </a:r>
+            <a:endParaRPr lang="en-US" sz="1000" dirty="0"/>
+          </a:p>
+        </p:txBody>
+      </p:sp>
+    </p:spTree>
+    <p:extLst>
+      <p:ext uri="{BB962C8B-B14F-4D97-AF65-F5344CB8AC3E}">
+        <p14:creationId xmlns:p14="http://schemas.microsoft.com/office/powerpoint/2010/main" val="303619527"/>
+      </p:ext>
+    </p:extLst>
+  </p:cSld>
+  <p:clrMapOvr>
+    <a:masterClrMapping/>
+  </p:clrMapOvr>
+</p:sld>
+</file>
+
+<file path=ppt/slides/slide53.xml><?xml version="1.0" encoding="utf-8"?>
+<p:sld xmlns:a="http://schemas.openxmlformats.org/drawingml/2006/main" xmlns:r="http://schemas.openxmlformats.org/officeDocument/2006/relationships" xmlns:p="http://schemas.openxmlformats.org/presentationml/2006/main">
+  <p:cSld name="Slide 8">
+    <p:bg>
+      <p:bgPr>
+        <a:solidFill>
+          <a:srgbClr val="FFFFFF"/>
+        </a:solidFill>
+        <a:effectLst/>
+      </p:bgPr>
+    </p:bg>
+    <p:spTree>
+      <p:nvGrpSpPr>
+        <p:cNvPr id="1" name=""/>
+        <p:cNvGrpSpPr/>
+        <p:nvPr/>
+      </p:nvGrpSpPr>
+      <p:grpSpPr>
+        <a:xfrm>
+          <a:off x="0" y="0"/>
+          <a:ext cx="0" cy="0"/>
+          <a:chOff x="0" y="0"/>
+          <a:chExt cx="0" cy="0"/>
+        </a:xfrm>
+      </p:grpSpPr>
+      <p:sp>
+        <p:nvSpPr>
+          <p:cNvPr id="2" name="Shape 0"/>
+          <p:cNvSpPr/>
+          <p:nvPr/>
+        </p:nvSpPr>
+        <p:spPr>
+          <a:xfrm>
+            <a:off x="0" y="0"/>
+            <a:ext cx="9144000" cy="822960"/>
+          </a:xfrm>
+          <a:prstGeom prst="rect">
+            <a:avLst/>
+          </a:prstGeom>
+          <a:solidFill>
+            <a:srgbClr val="024731"/>
+          </a:solidFill>
+          <a:ln/>
+        </p:spPr>
+        <p:txBody>
+          <a:bodyPr/>
+          <a:lstStyle/>
+          <a:p>
+            <a:endParaRPr lang="en-US"/>
+          </a:p>
+        </p:txBody>
+      </p:sp>
+      <p:sp>
+        <p:nvSpPr>
+          <p:cNvPr id="3" name="Text 1"/>
+          <p:cNvSpPr/>
+          <p:nvPr/>
+        </p:nvSpPr>
+        <p:spPr>
+          <a:xfrm>
+            <a:off x="548640" y="137160"/>
+            <a:ext cx="7315200" cy="274320"/>
+          </a:xfrm>
+          <a:prstGeom prst="rect">
+            <a:avLst/>
+          </a:prstGeom>
+          <a:noFill/>
+          <a:ln/>
+        </p:spPr>
+        <p:txBody>
+          <a:bodyPr wrap="square" lIns="0" tIns="0" rIns="0" bIns="0" rtlCol="0" anchor="ctr"/>
+          <a:lstStyle/>
+          <a:p>
+            <a:pPr marL="0" indent="0">
+              <a:buNone/>
+            </a:pPr>
+            <a:r>
+              <a:rPr lang="en-US" sz="2000" b="1" dirty="0">
+                <a:solidFill>
+                  <a:srgbClr val="FFFFFF"/>
+                </a:solidFill>
+                <a:latin typeface="Open Sans" pitchFamily="34" charset="0"/>
+                <a:ea typeface="Open Sans" pitchFamily="34" charset="-122"/>
+                <a:cs typeface="Open Sans" pitchFamily="34" charset="-120"/>
+              </a:rPr>
+              <a:t>Why Accounting Standards Matter</a:t>
+            </a:r>
+            <a:endParaRPr lang="en-US" sz="2000" dirty="0"/>
+          </a:p>
+        </p:txBody>
+      </p:sp>
+      <p:sp>
+        <p:nvSpPr>
+          <p:cNvPr id="4" name="Text 2"/>
+          <p:cNvSpPr/>
+          <p:nvPr/>
+        </p:nvSpPr>
+        <p:spPr>
+          <a:xfrm>
+            <a:off x="548640" y="429768"/>
+            <a:ext cx="7315200" cy="228600"/>
+          </a:xfrm>
+          <a:prstGeom prst="rect">
+            <a:avLst/>
+          </a:prstGeom>
+          <a:noFill/>
+          <a:ln/>
+        </p:spPr>
+        <p:txBody>
+          <a:bodyPr wrap="square" lIns="0" tIns="0" rIns="0" bIns="0" rtlCol="0" anchor="ctr"/>
+          <a:lstStyle/>
+          <a:p>
+            <a:pPr marL="0" indent="0">
+              <a:buNone/>
+            </a:pPr>
+            <a:r>
+              <a:rPr lang="en-US" sz="1100" dirty="0">
+                <a:solidFill>
+                  <a:srgbClr val="B8DDD1"/>
+                </a:solidFill>
+                <a:latin typeface="Open Sans" pitchFamily="34" charset="0"/>
+                <a:ea typeface="Open Sans" pitchFamily="34" charset="-122"/>
+                <a:cs typeface="Open Sans" pitchFamily="34" charset="-120"/>
+              </a:rPr>
+              <a:t>Appendix C  |  Non-US companies report under different frameworks — your ratios must account for this</a:t>
+            </a:r>
+            <a:endParaRPr lang="en-US" sz="1100" dirty="0"/>
+          </a:p>
+        </p:txBody>
+      </p:sp>
+      <p:sp>
+        <p:nvSpPr>
+          <p:cNvPr id="5" name="Text 3"/>
+          <p:cNvSpPr/>
+          <p:nvPr/>
+        </p:nvSpPr>
+        <p:spPr>
+          <a:xfrm>
+            <a:off x="548640" y="1051560"/>
+            <a:ext cx="4114800" cy="274320"/>
+          </a:xfrm>
+          <a:prstGeom prst="rect">
+            <a:avLst/>
+          </a:prstGeom>
+          <a:noFill/>
+          <a:ln/>
+        </p:spPr>
+        <p:txBody>
+          <a:bodyPr wrap="square" lIns="0" tIns="0" rIns="0" bIns="0" rtlCol="0" anchor="ctr"/>
+          <a:lstStyle/>
+          <a:p>
+            <a:pPr marL="0" indent="0">
+              <a:buNone/>
+            </a:pPr>
+            <a:r>
+              <a:rPr lang="en-US" sz="1400" b="1" dirty="0">
+                <a:solidFill>
+                  <a:srgbClr val="024731"/>
+                </a:solidFill>
+                <a:latin typeface="Open Sans" pitchFamily="34" charset="0"/>
+                <a:ea typeface="Open Sans" pitchFamily="34" charset="-122"/>
+                <a:cs typeface="Open Sans" pitchFamily="34" charset="-120"/>
+              </a:rPr>
+              <a:t>The Problem</a:t>
+            </a:r>
+            <a:endParaRPr lang="en-US" sz="1400" dirty="0"/>
+          </a:p>
+        </p:txBody>
+      </p:sp>
+      <p:sp>
+        <p:nvSpPr>
+          <p:cNvPr id="6" name="Shape 4"/>
+          <p:cNvSpPr/>
+          <p:nvPr/>
+        </p:nvSpPr>
+        <p:spPr>
+          <a:xfrm>
+            <a:off x="548640" y="1417320"/>
+            <a:ext cx="4114800" cy="502920"/>
+          </a:xfrm>
+          <a:prstGeom prst="rect">
+            <a:avLst/>
+          </a:prstGeom>
+          <a:solidFill>
+            <a:srgbClr val="E6F2EF"/>
+          </a:solidFill>
+          <a:ln/>
+        </p:spPr>
+        <p:txBody>
+          <a:bodyPr/>
+          <a:lstStyle/>
+          <a:p>
+            <a:endParaRPr lang="en-US"/>
+          </a:p>
+        </p:txBody>
+      </p:sp>
+      <p:sp>
+        <p:nvSpPr>
+          <p:cNvPr id="7" name="Text 5"/>
+          <p:cNvSpPr/>
+          <p:nvPr/>
+        </p:nvSpPr>
+        <p:spPr>
+          <a:xfrm>
+            <a:off x="685800" y="1463040"/>
+            <a:ext cx="3840480" cy="411480"/>
+          </a:xfrm>
+          <a:prstGeom prst="rect">
+            <a:avLst/>
+          </a:prstGeom>
+          <a:noFill/>
+          <a:ln/>
+        </p:spPr>
+        <p:txBody>
+          <a:bodyPr wrap="square" rtlCol="0" anchor="ctr"/>
+          <a:lstStyle/>
+          <a:p>
+            <a:pPr marL="0" indent="0">
+              <a:buNone/>
+            </a:pPr>
+            <a:r>
+              <a:rPr lang="en-US" sz="1100" b="1" dirty="0">
+                <a:solidFill>
+                  <a:srgbClr val="024731"/>
+                </a:solidFill>
+                <a:latin typeface="Open Sans" pitchFamily="34" charset="0"/>
+                <a:ea typeface="Open Sans" pitchFamily="34" charset="-122"/>
+                <a:cs typeface="Open Sans" pitchFamily="34" charset="-120"/>
+              </a:rPr>
+              <a:t>Vietnamese firms report under VAS</a:t>
+            </a:r>
+            <a:endParaRPr lang="en-US" sz="1100" dirty="0"/>
+          </a:p>
+          <a:p>
+            <a:pPr marL="0" indent="0">
+              <a:buNone/>
+            </a:pPr>
+            <a:r>
+              <a:rPr lang="en-US" sz="1100" dirty="0">
+                <a:solidFill>
+                  <a:srgbClr val="024731"/>
+                </a:solidFill>
+                <a:latin typeface="Open Sans" pitchFamily="34" charset="0"/>
+                <a:ea typeface="Open Sans" pitchFamily="34" charset="-122"/>
+                <a:cs typeface="Open Sans" pitchFamily="34" charset="-120"/>
+              </a:rPr>
+              <a:t xml:space="preserve">    which differs from US GAAP and IFRS</a:t>
+            </a:r>
+            <a:endParaRPr lang="en-US" sz="1100" dirty="0"/>
+          </a:p>
+        </p:txBody>
+      </p:sp>
+      <p:sp>
+        <p:nvSpPr>
+          <p:cNvPr id="8" name="Shape 6"/>
+          <p:cNvSpPr/>
+          <p:nvPr/>
+        </p:nvSpPr>
+        <p:spPr>
+          <a:xfrm>
+            <a:off x="548640" y="2011680"/>
+            <a:ext cx="4114800" cy="502920"/>
+          </a:xfrm>
+          <a:prstGeom prst="rect">
+            <a:avLst/>
+          </a:prstGeom>
+          <a:solidFill>
+            <a:srgbClr val="E6F2EF"/>
+          </a:solidFill>
+          <a:ln/>
+        </p:spPr>
+        <p:txBody>
+          <a:bodyPr/>
+          <a:lstStyle/>
+          <a:p>
+            <a:endParaRPr lang="en-US"/>
+          </a:p>
+        </p:txBody>
+      </p:sp>
+      <p:sp>
+        <p:nvSpPr>
+          <p:cNvPr id="9" name="Text 7"/>
+          <p:cNvSpPr/>
+          <p:nvPr/>
+        </p:nvSpPr>
+        <p:spPr>
+          <a:xfrm>
+            <a:off x="685800" y="2057400"/>
+            <a:ext cx="3840480" cy="411480"/>
+          </a:xfrm>
+          <a:prstGeom prst="rect">
+            <a:avLst/>
+          </a:prstGeom>
+          <a:noFill/>
+          <a:ln/>
+        </p:spPr>
+        <p:txBody>
+          <a:bodyPr wrap="square" rtlCol="0" anchor="ctr"/>
+          <a:lstStyle/>
+          <a:p>
+            <a:pPr marL="0" indent="0">
+              <a:buNone/>
+            </a:pPr>
+            <a:r>
+              <a:rPr lang="en-US" sz="1100" b="1" dirty="0">
+                <a:solidFill>
+                  <a:srgbClr val="024731"/>
+                </a:solidFill>
+                <a:latin typeface="Open Sans" pitchFamily="34" charset="0"/>
+                <a:ea typeface="Open Sans" pitchFamily="34" charset="-122"/>
+                <a:cs typeface="Open Sans" pitchFamily="34" charset="-120"/>
+              </a:rPr>
+              <a:t>Ratios are only comparable if the</a:t>
+            </a:r>
+            <a:endParaRPr lang="en-US" sz="1100" dirty="0"/>
+          </a:p>
+          <a:p>
+            <a:pPr marL="0" indent="0">
+              <a:buNone/>
+            </a:pPr>
+            <a:r>
+              <a:rPr lang="en-US" sz="1100" dirty="0">
+                <a:solidFill>
+                  <a:srgbClr val="024731"/>
+                </a:solidFill>
+                <a:latin typeface="Open Sans" pitchFamily="34" charset="0"/>
+                <a:ea typeface="Open Sans" pitchFamily="34" charset="-122"/>
+                <a:cs typeface="Open Sans" pitchFamily="34" charset="-120"/>
+              </a:rPr>
+              <a:t xml:space="preserve">    underlying financials are on a comparable basis</a:t>
+            </a:r>
+            <a:endParaRPr lang="en-US" sz="1100" dirty="0"/>
+          </a:p>
+        </p:txBody>
+      </p:sp>
+      <p:sp>
+        <p:nvSpPr>
+          <p:cNvPr id="10" name="Shape 8"/>
+          <p:cNvSpPr/>
+          <p:nvPr/>
+        </p:nvSpPr>
+        <p:spPr>
+          <a:xfrm>
+            <a:off x="4937760" y="1051560"/>
+            <a:ext cx="3840480" cy="3749040"/>
+          </a:xfrm>
+          <a:prstGeom prst="rect">
+            <a:avLst/>
+          </a:prstGeom>
+          <a:solidFill>
+            <a:srgbClr val="F5F7F6"/>
+          </a:solidFill>
+          <a:ln/>
+          <a:effectLst>
+            <a:outerShdw blurRad="50800" dist="12700" dir="8100000" algn="bl" rotWithShape="0">
+              <a:srgbClr val="000000">
+                <a:alpha val="10000"/>
+              </a:srgbClr>
+            </a:outerShdw>
+          </a:effectLst>
+        </p:spPr>
+        <p:txBody>
+          <a:bodyPr/>
+          <a:lstStyle/>
+          <a:p>
+            <a:endParaRPr lang="en-US"/>
+          </a:p>
+        </p:txBody>
+      </p:sp>
+      <p:sp>
+        <p:nvSpPr>
+          <p:cNvPr id="11" name="Text 9"/>
+          <p:cNvSpPr/>
+          <p:nvPr/>
+        </p:nvSpPr>
+        <p:spPr>
+          <a:xfrm>
+            <a:off x="4946904" y="1143000"/>
+            <a:ext cx="3822192" cy="320040"/>
+          </a:xfrm>
+          <a:prstGeom prst="rect">
+            <a:avLst/>
+          </a:prstGeom>
+          <a:noFill/>
+          <a:ln/>
+        </p:spPr>
+        <p:txBody>
+          <a:bodyPr wrap="square" lIns="0" tIns="0" rIns="0" bIns="0" rtlCol="0" anchor="ctr"/>
+          <a:lstStyle/>
+          <a:p>
+            <a:pPr marL="0" indent="0">
+              <a:buNone/>
+            </a:pPr>
+            <a:r>
+              <a:rPr lang="en-US" sz="1400" b="1" dirty="0">
+                <a:solidFill>
+                  <a:srgbClr val="024731"/>
+                </a:solidFill>
+                <a:latin typeface="Open Sans" pitchFamily="34" charset="0"/>
+                <a:ea typeface="Open Sans" pitchFamily="34" charset="-122"/>
+                <a:cs typeface="Open Sans" pitchFamily="34" charset="-120"/>
+              </a:rPr>
+              <a:t>Five Areas to Check</a:t>
+            </a:r>
+            <a:endParaRPr lang="en-US" sz="1400" dirty="0"/>
+          </a:p>
+        </p:txBody>
+      </p:sp>
+      <p:sp>
+        <p:nvSpPr>
+          <p:cNvPr id="12" name="Text 10"/>
+          <p:cNvSpPr/>
+          <p:nvPr/>
+        </p:nvSpPr>
+        <p:spPr>
+          <a:xfrm>
+            <a:off x="5120640" y="1417320"/>
+            <a:ext cx="3474720" cy="228600"/>
+          </a:xfrm>
+          <a:prstGeom prst="rect">
+            <a:avLst/>
+          </a:prstGeom>
+          <a:noFill/>
+          <a:ln/>
+        </p:spPr>
+        <p:txBody>
+          <a:bodyPr wrap="square" lIns="0" tIns="0" rIns="0" bIns="0" rtlCol="0" anchor="ctr"/>
+          <a:lstStyle/>
+          <a:p>
+            <a:pPr marL="0" indent="0">
+              <a:buNone/>
+            </a:pPr>
+            <a:r>
+              <a:rPr lang="en-US" sz="900" i="1" dirty="0">
+                <a:solidFill>
+                  <a:srgbClr val="6B7280"/>
+                </a:solidFill>
+                <a:latin typeface="Open Sans" pitchFamily="34" charset="0"/>
+                <a:ea typeface="Open Sans" pitchFamily="34" charset="-122"/>
+                <a:cs typeface="Open Sans" pitchFamily="34" charset="-120"/>
+              </a:rPr>
+              <a:t>Check each when using non-US-GAAP data</a:t>
+            </a:r>
+            <a:endParaRPr lang="en-US" sz="900" dirty="0"/>
+          </a:p>
+        </p:txBody>
+      </p:sp>
+      <p:sp>
+        <p:nvSpPr>
+          <p:cNvPr id="13" name="Shape 11"/>
+          <p:cNvSpPr/>
+          <p:nvPr/>
+        </p:nvSpPr>
+        <p:spPr>
+          <a:xfrm>
+            <a:off x="5212080" y="1783080"/>
+            <a:ext cx="201168" cy="201168"/>
+          </a:xfrm>
+          <a:prstGeom prst="rect">
+            <a:avLst/>
+          </a:prstGeom>
+          <a:solidFill>
+            <a:srgbClr val="FFFFFF"/>
+          </a:solidFill>
+          <a:ln w="19050">
+            <a:solidFill>
+              <a:srgbClr val="024731"/>
+            </a:solidFill>
+            <a:prstDash val="solid"/>
+          </a:ln>
+        </p:spPr>
+        <p:txBody>
+          <a:bodyPr/>
+          <a:lstStyle/>
+          <a:p>
+            <a:endParaRPr lang="en-US"/>
+          </a:p>
+        </p:txBody>
+      </p:sp>
+      <p:sp>
+        <p:nvSpPr>
+          <p:cNvPr id="14" name="Text 12"/>
+          <p:cNvSpPr/>
+          <p:nvPr/>
+        </p:nvSpPr>
+        <p:spPr>
+          <a:xfrm>
+            <a:off x="5532120" y="1764792"/>
+            <a:ext cx="3108960" cy="228600"/>
+          </a:xfrm>
+          <a:prstGeom prst="rect">
+            <a:avLst/>
+          </a:prstGeom>
+          <a:noFill/>
+          <a:ln/>
+        </p:spPr>
+        <p:txBody>
+          <a:bodyPr wrap="square" lIns="0" tIns="0" rIns="0" bIns="0" rtlCol="0" anchor="ctr"/>
+          <a:lstStyle/>
+          <a:p>
+            <a:pPr marL="0" indent="0">
+              <a:buNone/>
+            </a:pPr>
+            <a:r>
+              <a:rPr lang="en-US" sz="1000" dirty="0">
+                <a:solidFill>
+                  <a:srgbClr val="0D0D0D"/>
+                </a:solidFill>
+                <a:latin typeface="Open Sans" pitchFamily="34" charset="0"/>
+                <a:ea typeface="Open Sans" pitchFamily="34" charset="-122"/>
+                <a:cs typeface="Open Sans" pitchFamily="34" charset="-120"/>
+              </a:rPr>
+              <a:t>Inventory method (LIFO vs. FIFO)</a:t>
+            </a:r>
+            <a:endParaRPr lang="en-US" sz="1000" dirty="0"/>
+          </a:p>
+        </p:txBody>
+      </p:sp>
+      <p:sp>
+        <p:nvSpPr>
+          <p:cNvPr id="15" name="Shape 13"/>
+          <p:cNvSpPr/>
+          <p:nvPr/>
+        </p:nvSpPr>
+        <p:spPr>
+          <a:xfrm>
+            <a:off x="5212080" y="2130552"/>
+            <a:ext cx="201168" cy="201168"/>
+          </a:xfrm>
+          <a:prstGeom prst="rect">
+            <a:avLst/>
+          </a:prstGeom>
+          <a:solidFill>
+            <a:srgbClr val="FFFFFF"/>
+          </a:solidFill>
+          <a:ln w="19050">
+            <a:solidFill>
+              <a:srgbClr val="024731"/>
+            </a:solidFill>
+            <a:prstDash val="solid"/>
+          </a:ln>
+        </p:spPr>
+        <p:txBody>
+          <a:bodyPr/>
+          <a:lstStyle/>
+          <a:p>
+            <a:endParaRPr lang="en-US"/>
+          </a:p>
+        </p:txBody>
+      </p:sp>
+      <p:sp>
+        <p:nvSpPr>
+          <p:cNvPr id="16" name="Text 14"/>
+          <p:cNvSpPr/>
+          <p:nvPr/>
+        </p:nvSpPr>
+        <p:spPr>
+          <a:xfrm>
+            <a:off x="5532120" y="2112264"/>
+            <a:ext cx="3108960" cy="228600"/>
+          </a:xfrm>
+          <a:prstGeom prst="rect">
+            <a:avLst/>
+          </a:prstGeom>
+          <a:noFill/>
+          <a:ln/>
+        </p:spPr>
+        <p:txBody>
+          <a:bodyPr wrap="square" lIns="0" tIns="0" rIns="0" bIns="0" rtlCol="0" anchor="ctr"/>
+          <a:lstStyle/>
+          <a:p>
+            <a:pPr marL="0" indent="0">
+              <a:buNone/>
+            </a:pPr>
+            <a:r>
+              <a:rPr lang="en-US" sz="1000" dirty="0">
+                <a:solidFill>
+                  <a:srgbClr val="0D0D0D"/>
+                </a:solidFill>
+                <a:latin typeface="Open Sans" pitchFamily="34" charset="0"/>
+                <a:ea typeface="Open Sans" pitchFamily="34" charset="-122"/>
+                <a:cs typeface="Open Sans" pitchFamily="34" charset="-120"/>
+              </a:rPr>
+              <a:t>Leases (IFRS 16 vs. VAS off-BS)</a:t>
+            </a:r>
+            <a:endParaRPr lang="en-US" sz="1000" dirty="0"/>
+          </a:p>
+        </p:txBody>
+      </p:sp>
+      <p:sp>
+        <p:nvSpPr>
+          <p:cNvPr id="17" name="Shape 15"/>
+          <p:cNvSpPr/>
+          <p:nvPr/>
+        </p:nvSpPr>
+        <p:spPr>
+          <a:xfrm>
+            <a:off x="5212080" y="2478024"/>
+            <a:ext cx="201168" cy="201168"/>
+          </a:xfrm>
+          <a:prstGeom prst="rect">
+            <a:avLst/>
+          </a:prstGeom>
+          <a:solidFill>
+            <a:srgbClr val="FFFFFF"/>
+          </a:solidFill>
+          <a:ln w="19050">
+            <a:solidFill>
+              <a:srgbClr val="024731"/>
+            </a:solidFill>
+            <a:prstDash val="solid"/>
+          </a:ln>
+        </p:spPr>
+        <p:txBody>
+          <a:bodyPr/>
+          <a:lstStyle/>
+          <a:p>
+            <a:endParaRPr lang="en-US"/>
+          </a:p>
+        </p:txBody>
+      </p:sp>
+      <p:sp>
+        <p:nvSpPr>
+          <p:cNvPr id="18" name="Text 16"/>
+          <p:cNvSpPr/>
+          <p:nvPr/>
+        </p:nvSpPr>
+        <p:spPr>
+          <a:xfrm>
+            <a:off x="5532120" y="2459736"/>
+            <a:ext cx="3108960" cy="228600"/>
+          </a:xfrm>
+          <a:prstGeom prst="rect">
+            <a:avLst/>
+          </a:prstGeom>
+          <a:noFill/>
+          <a:ln/>
+        </p:spPr>
+        <p:txBody>
+          <a:bodyPr wrap="square" lIns="0" tIns="0" rIns="0" bIns="0" rtlCol="0" anchor="ctr"/>
+          <a:lstStyle/>
+          <a:p>
+            <a:pPr marL="0" indent="0">
+              <a:buNone/>
+            </a:pPr>
+            <a:r>
+              <a:rPr lang="en-US" sz="1000" dirty="0">
+                <a:solidFill>
+                  <a:srgbClr val="0D0D0D"/>
+                </a:solidFill>
+                <a:latin typeface="Open Sans" pitchFamily="34" charset="0"/>
+                <a:ea typeface="Open Sans" pitchFamily="34" charset="-122"/>
+                <a:cs typeface="Open Sans" pitchFamily="34" charset="-120"/>
+              </a:rPr>
+              <a:t>R&amp;D / development cost capitalization</a:t>
+            </a:r>
+            <a:endParaRPr lang="en-US" sz="1000" dirty="0"/>
+          </a:p>
+        </p:txBody>
+      </p:sp>
+      <p:sp>
+        <p:nvSpPr>
+          <p:cNvPr id="19" name="Shape 17"/>
+          <p:cNvSpPr/>
+          <p:nvPr/>
+        </p:nvSpPr>
+        <p:spPr>
+          <a:xfrm>
+            <a:off x="5212080" y="2825496"/>
+            <a:ext cx="201168" cy="201168"/>
+          </a:xfrm>
+          <a:prstGeom prst="rect">
+            <a:avLst/>
+          </a:prstGeom>
+          <a:solidFill>
+            <a:srgbClr val="FFFFFF"/>
+          </a:solidFill>
+          <a:ln w="19050">
+            <a:solidFill>
+              <a:srgbClr val="024731"/>
+            </a:solidFill>
+            <a:prstDash val="solid"/>
+          </a:ln>
+        </p:spPr>
+        <p:txBody>
+          <a:bodyPr/>
+          <a:lstStyle/>
+          <a:p>
+            <a:endParaRPr lang="en-US"/>
+          </a:p>
+        </p:txBody>
+      </p:sp>
+      <p:sp>
+        <p:nvSpPr>
+          <p:cNvPr id="20" name="Text 18"/>
+          <p:cNvSpPr/>
+          <p:nvPr/>
+        </p:nvSpPr>
+        <p:spPr>
+          <a:xfrm>
+            <a:off x="5532120" y="2807208"/>
+            <a:ext cx="3108960" cy="228600"/>
+          </a:xfrm>
+          <a:prstGeom prst="rect">
+            <a:avLst/>
+          </a:prstGeom>
+          <a:noFill/>
+          <a:ln/>
+        </p:spPr>
+        <p:txBody>
+          <a:bodyPr wrap="square" lIns="0" tIns="0" rIns="0" bIns="0" rtlCol="0" anchor="ctr"/>
+          <a:lstStyle/>
+          <a:p>
+            <a:pPr marL="0" indent="0">
+              <a:buNone/>
+            </a:pPr>
+            <a:r>
+              <a:rPr lang="en-US" sz="1000" dirty="0">
+                <a:solidFill>
+                  <a:srgbClr val="0D0D0D"/>
+                </a:solidFill>
+                <a:latin typeface="Open Sans" pitchFamily="34" charset="0"/>
+                <a:ea typeface="Open Sans" pitchFamily="34" charset="-122"/>
+                <a:cs typeface="Open Sans" pitchFamily="34" charset="-120"/>
+              </a:rPr>
+              <a:t>Impairment reversals (IFRS allows)</a:t>
+            </a:r>
+            <a:endParaRPr lang="en-US" sz="1000" dirty="0"/>
+          </a:p>
+        </p:txBody>
+      </p:sp>
+      <p:sp>
+        <p:nvSpPr>
+          <p:cNvPr id="21" name="Shape 19"/>
+          <p:cNvSpPr/>
+          <p:nvPr/>
+        </p:nvSpPr>
+        <p:spPr>
+          <a:xfrm>
+            <a:off x="5212080" y="3172968"/>
+            <a:ext cx="201168" cy="201168"/>
+          </a:xfrm>
+          <a:prstGeom prst="rect">
+            <a:avLst/>
+          </a:prstGeom>
+          <a:solidFill>
+            <a:srgbClr val="FFFFFF"/>
+          </a:solidFill>
+          <a:ln w="19050">
+            <a:solidFill>
+              <a:srgbClr val="024731"/>
+            </a:solidFill>
+            <a:prstDash val="solid"/>
+          </a:ln>
+        </p:spPr>
+        <p:txBody>
+          <a:bodyPr/>
+          <a:lstStyle/>
+          <a:p>
+            <a:endParaRPr lang="en-US"/>
+          </a:p>
+        </p:txBody>
+      </p:sp>
+      <p:sp>
+        <p:nvSpPr>
+          <p:cNvPr id="22" name="Text 20"/>
+          <p:cNvSpPr/>
+          <p:nvPr/>
+        </p:nvSpPr>
+        <p:spPr>
+          <a:xfrm>
+            <a:off x="5532120" y="3154680"/>
+            <a:ext cx="3108960" cy="228600"/>
+          </a:xfrm>
+          <a:prstGeom prst="rect">
+            <a:avLst/>
+          </a:prstGeom>
+          <a:noFill/>
+          <a:ln/>
+        </p:spPr>
+        <p:txBody>
+          <a:bodyPr wrap="square" lIns="0" tIns="0" rIns="0" bIns="0" rtlCol="0" anchor="ctr"/>
+          <a:lstStyle/>
+          <a:p>
+            <a:pPr marL="0" indent="0">
+              <a:buNone/>
+            </a:pPr>
+            <a:r>
+              <a:rPr lang="en-US" sz="1000" dirty="0">
+                <a:solidFill>
+                  <a:srgbClr val="0D0D0D"/>
+                </a:solidFill>
+                <a:latin typeface="Open Sans" pitchFamily="34" charset="0"/>
+                <a:ea typeface="Open Sans" pitchFamily="34" charset="-122"/>
+                <a:cs typeface="Open Sans" pitchFamily="34" charset="-120"/>
+              </a:rPr>
+              <a:t>Revenue recognition timing</a:t>
+            </a:r>
+            <a:endParaRPr lang="en-US" sz="1000" dirty="0"/>
+          </a:p>
+        </p:txBody>
+      </p:sp>
+      <p:sp>
+        <p:nvSpPr>
+          <p:cNvPr id="23" name="Shape 21"/>
+          <p:cNvSpPr/>
+          <p:nvPr/>
+        </p:nvSpPr>
+        <p:spPr>
+          <a:xfrm>
+            <a:off x="5212080" y="3520440"/>
+            <a:ext cx="201168" cy="201168"/>
+          </a:xfrm>
+          <a:prstGeom prst="rect">
+            <a:avLst/>
+          </a:prstGeom>
+          <a:solidFill>
+            <a:srgbClr val="FFFFFF"/>
+          </a:solidFill>
+          <a:ln w="19050">
+            <a:solidFill>
+              <a:srgbClr val="024731"/>
+            </a:solidFill>
+            <a:prstDash val="solid"/>
+          </a:ln>
+        </p:spPr>
+        <p:txBody>
+          <a:bodyPr/>
+          <a:lstStyle/>
+          <a:p>
+            <a:endParaRPr lang="en-US"/>
+          </a:p>
+        </p:txBody>
+      </p:sp>
+      <p:sp>
+        <p:nvSpPr>
+          <p:cNvPr id="24" name="Text 22"/>
+          <p:cNvSpPr/>
+          <p:nvPr/>
+        </p:nvSpPr>
+        <p:spPr>
+          <a:xfrm>
+            <a:off x="5532120" y="3502152"/>
+            <a:ext cx="3108960" cy="228600"/>
+          </a:xfrm>
+          <a:prstGeom prst="rect">
+            <a:avLst/>
+          </a:prstGeom>
+          <a:noFill/>
+          <a:ln/>
+        </p:spPr>
+        <p:txBody>
+          <a:bodyPr wrap="square" lIns="0" tIns="0" rIns="0" bIns="0" rtlCol="0" anchor="ctr"/>
+          <a:lstStyle/>
+          <a:p>
+            <a:pPr marL="0" indent="0">
+              <a:buNone/>
+            </a:pPr>
+            <a:r>
+              <a:rPr lang="en-US" sz="1000" dirty="0">
+                <a:solidFill>
+                  <a:srgbClr val="0D0D0D"/>
+                </a:solidFill>
+                <a:latin typeface="Open Sans" pitchFamily="34" charset="0"/>
+                <a:ea typeface="Open Sans" pitchFamily="34" charset="-122"/>
+                <a:cs typeface="Open Sans" pitchFamily="34" charset="-120"/>
+              </a:rPr>
+              <a:t>GAAP Bridge tab completed</a:t>
+            </a:r>
+            <a:endParaRPr lang="en-US" sz="1000" dirty="0"/>
+          </a:p>
+        </p:txBody>
+      </p:sp>
+      <p:sp>
+        <p:nvSpPr>
+          <p:cNvPr id="29" name="Shape 27"/>
+          <p:cNvSpPr/>
+          <p:nvPr/>
+        </p:nvSpPr>
+        <p:spPr>
+          <a:xfrm>
+            <a:off x="548640" y="4434840"/>
+            <a:ext cx="4114800" cy="457200"/>
+          </a:xfrm>
+          <a:prstGeom prst="rect">
+            <a:avLst/>
+          </a:prstGeom>
+          <a:solidFill>
+            <a:srgbClr val="024731"/>
+          </a:solidFill>
+          <a:ln/>
+        </p:spPr>
+        <p:txBody>
+          <a:bodyPr/>
+          <a:lstStyle/>
+          <a:p>
+            <a:endParaRPr lang="en-US"/>
+          </a:p>
+        </p:txBody>
+      </p:sp>
+      <p:sp>
+        <p:nvSpPr>
+          <p:cNvPr id="30" name="Text 28"/>
+          <p:cNvSpPr/>
+          <p:nvPr/>
+        </p:nvSpPr>
+        <p:spPr>
+          <a:xfrm>
+            <a:off x="685800" y="4453128"/>
+            <a:ext cx="3840480" cy="411480"/>
+          </a:xfrm>
+          <a:prstGeom prst="rect">
+            <a:avLst/>
+          </a:prstGeom>
+          <a:noFill/>
+          <a:ln/>
+        </p:spPr>
+        <p:txBody>
+          <a:bodyPr wrap="square" rtlCol="0" anchor="ctr"/>
+          <a:lstStyle/>
+          <a:p>
+            <a:pPr marL="0" indent="0">
+              <a:buNone/>
+            </a:pPr>
+            <a:r>
+              <a:rPr lang="en-US" sz="1000" dirty="0">
+                <a:solidFill>
+                  <a:srgbClr val="FFFFFF"/>
+                </a:solidFill>
+                <a:latin typeface="Open Sans" pitchFamily="34" charset="0"/>
+                <a:ea typeface="Open Sans" pitchFamily="34" charset="-122"/>
+                <a:cs typeface="Open Sans" pitchFamily="34" charset="-120"/>
+              </a:rPr>
+              <a:t>You are graded on quality of disclosure, not on performing a full conversion. Identify the standard, check the five areas, note what you found.</a:t>
+            </a:r>
+            <a:endParaRPr lang="en-US" sz="1000" dirty="0"/>
+          </a:p>
+        </p:txBody>
+      </p:sp>
+    </p:spTree>
+  </p:cSld>
+  <p:clrMapOvr>
+    <a:masterClrMapping/>
+  </p:clrMapOvr>
+</p:sld>
+</file>
+
+<file path=ppt/slides/slide54.xml><?xml version="1.0" encoding="utf-8"?>
+<p:sld xmlns:a="http://schemas.openxmlformats.org/drawingml/2006/main" xmlns:r="http://schemas.openxmlformats.org/officeDocument/2006/relationships" xmlns:p="http://schemas.openxmlformats.org/presentationml/2006/main">
+  <p:cSld name="Slide 8">
+    <p:bg>
+      <p:bgPr>
+        <a:solidFill>
+          <a:srgbClr val="FFFFFF"/>
+        </a:solidFill>
+        <a:effectLst/>
+      </p:bgPr>
+    </p:bg>
+    <p:spTree>
+      <p:nvGrpSpPr>
+        <p:cNvPr id="1" name=""/>
+        <p:cNvGrpSpPr/>
+        <p:nvPr/>
+      </p:nvGrpSpPr>
+      <p:grpSpPr>
+        <a:xfrm>
+          <a:off x="0" y="0"/>
+          <a:ext cx="0" cy="0"/>
+          <a:chOff x="0" y="0"/>
+          <a:chExt cx="0" cy="0"/>
+        </a:xfrm>
+      </p:grpSpPr>
+      <p:sp>
+        <p:nvSpPr>
+          <p:cNvPr id="2" name="Shape 0"/>
+          <p:cNvSpPr/>
+          <p:nvPr/>
+        </p:nvSpPr>
+        <p:spPr>
+          <a:xfrm>
+            <a:off x="0" y="0"/>
+            <a:ext cx="9144000" cy="822960"/>
+          </a:xfrm>
+          <a:prstGeom prst="rect">
+            <a:avLst/>
+          </a:prstGeom>
+          <a:solidFill>
+            <a:srgbClr val="024731"/>
+          </a:solidFill>
+          <a:ln/>
+        </p:spPr>
+        <p:txBody>
+          <a:bodyPr/>
+          <a:lstStyle/>
+          <a:p>
+            <a:endParaRPr lang="en-US"/>
+          </a:p>
+        </p:txBody>
+      </p:sp>
+      <p:sp>
+        <p:nvSpPr>
+          <p:cNvPr id="3" name="Text 1"/>
+          <p:cNvSpPr/>
+          <p:nvPr/>
+        </p:nvSpPr>
+        <p:spPr>
+          <a:xfrm>
+            <a:off x="548640" y="137160"/>
+            <a:ext cx="7315200" cy="274320"/>
+          </a:xfrm>
+          <a:prstGeom prst="rect">
+            <a:avLst/>
+          </a:prstGeom>
+          <a:noFill/>
+          <a:ln/>
+        </p:spPr>
+        <p:txBody>
+          <a:bodyPr wrap="square" lIns="0" tIns="0" rIns="0" bIns="0" rtlCol="0" anchor="ctr"/>
+          <a:lstStyle/>
+          <a:p>
+            <a:pPr marL="0" indent="0">
+              <a:buNone/>
+            </a:pPr>
+            <a:r>
+              <a:rPr lang="en-US" sz="2000" b="1" dirty="0">
+                <a:solidFill>
+                  <a:srgbClr val="FFFFFF"/>
+                </a:solidFill>
+                <a:latin typeface="Open Sans" pitchFamily="34" charset="0"/>
+                <a:ea typeface="Open Sans" pitchFamily="34" charset="-122"/>
+                <a:cs typeface="Open Sans" pitchFamily="34" charset="-120"/>
+              </a:rPr>
+              <a:t>What You Need to Do</a:t>
+            </a:r>
+            <a:endParaRPr lang="en-US" sz="2000" dirty="0"/>
+          </a:p>
+        </p:txBody>
+      </p:sp>
+      <p:sp>
+        <p:nvSpPr>
+          <p:cNvPr id="4" name="Text 2"/>
+          <p:cNvSpPr/>
+          <p:nvPr/>
+        </p:nvSpPr>
+        <p:spPr>
+          <a:xfrm>
+            <a:off x="548640" y="429768"/>
+            <a:ext cx="7315200" cy="228600"/>
+          </a:xfrm>
+          <a:prstGeom prst="rect">
+            <a:avLst/>
+          </a:prstGeom>
+          <a:noFill/>
+          <a:ln/>
+        </p:spPr>
+        <p:txBody>
+          <a:bodyPr wrap="square" lIns="0" tIns="0" rIns="0" bIns="0" rtlCol="0" anchor="ctr"/>
+          <a:lstStyle/>
+          <a:p>
+            <a:pPr marL="0" indent="0">
+              <a:buNone/>
+            </a:pPr>
+            <a:r>
+              <a:rPr lang="en-US" sz="1100" dirty="0">
+                <a:solidFill>
+                  <a:srgbClr val="B8DDD1"/>
+                </a:solidFill>
+                <a:latin typeface="Open Sans" pitchFamily="34" charset="0"/>
+                <a:ea typeface="Open Sans" pitchFamily="34" charset="-122"/>
+                <a:cs typeface="Open Sans" pitchFamily="34" charset="-120"/>
+              </a:rPr>
+              <a:t>Appendix C  |  Four steps when your company reports under VAS, IFRS, CAS, or another non-US standard</a:t>
+            </a:r>
+            <a:endParaRPr lang="en-US" sz="1100" dirty="0"/>
+          </a:p>
+        </p:txBody>
+      </p:sp>
+      <p:sp>
+        <p:nvSpPr>
+          <p:cNvPr id="5" name="Text 3"/>
+          <p:cNvSpPr/>
+          <p:nvPr/>
+        </p:nvSpPr>
+        <p:spPr>
+          <a:xfrm>
+            <a:off x="548640" y="1051560"/>
+            <a:ext cx="4114800" cy="274320"/>
+          </a:xfrm>
+          <a:prstGeom prst="rect">
+            <a:avLst/>
+          </a:prstGeom>
+          <a:noFill/>
+          <a:ln/>
+        </p:spPr>
+        <p:txBody>
+          <a:bodyPr wrap="square" lIns="0" tIns="0" rIns="0" bIns="0" rtlCol="0" anchor="ctr"/>
+          <a:lstStyle/>
+          <a:p>
+            <a:pPr marL="0" indent="0">
+              <a:buNone/>
+            </a:pPr>
+            <a:r>
+              <a:rPr lang="en-US" sz="1400" b="1" dirty="0">
+                <a:solidFill>
+                  <a:srgbClr val="024731"/>
+                </a:solidFill>
+                <a:latin typeface="Open Sans" pitchFamily="34" charset="0"/>
+                <a:ea typeface="Open Sans" pitchFamily="34" charset="-122"/>
+                <a:cs typeface="Open Sans" pitchFamily="34" charset="-120"/>
+              </a:rPr>
+              <a:t>Four Steps</a:t>
+            </a:r>
+            <a:endParaRPr lang="en-US" sz="1400" dirty="0"/>
+          </a:p>
+        </p:txBody>
+      </p:sp>
+      <p:sp>
+        <p:nvSpPr>
+          <p:cNvPr id="6" name="Shape 4"/>
+          <p:cNvSpPr/>
+          <p:nvPr/>
+        </p:nvSpPr>
+        <p:spPr>
+          <a:xfrm>
+            <a:off x="548640" y="1417320"/>
+            <a:ext cx="4114800" cy="502920"/>
+          </a:xfrm>
+          <a:prstGeom prst="rect">
+            <a:avLst/>
+          </a:prstGeom>
+          <a:solidFill>
+            <a:srgbClr val="E6F2EF"/>
+          </a:solidFill>
+          <a:ln/>
+        </p:spPr>
+        <p:txBody>
+          <a:bodyPr/>
+          <a:lstStyle/>
+          <a:p>
+            <a:endParaRPr lang="en-US"/>
+          </a:p>
+        </p:txBody>
+      </p:sp>
+      <p:sp>
+        <p:nvSpPr>
+          <p:cNvPr id="7" name="Text 5"/>
+          <p:cNvSpPr/>
+          <p:nvPr/>
+        </p:nvSpPr>
+        <p:spPr>
+          <a:xfrm>
+            <a:off x="685800" y="1463040"/>
+            <a:ext cx="3840480" cy="411480"/>
+          </a:xfrm>
+          <a:prstGeom prst="rect">
+            <a:avLst/>
+          </a:prstGeom>
+          <a:noFill/>
+          <a:ln/>
+        </p:spPr>
+        <p:txBody>
+          <a:bodyPr wrap="square" rtlCol="0" anchor="ctr"/>
+          <a:lstStyle/>
+          <a:p>
+            <a:pPr marL="0" indent="0">
+              <a:buNone/>
+            </a:pPr>
+            <a:r>
+              <a:rPr lang="en-US" sz="1100" b="1" dirty="0">
+                <a:solidFill>
+                  <a:srgbClr val="024731"/>
+                </a:solidFill>
+                <a:latin typeface="Open Sans" pitchFamily="34" charset="0"/>
+                <a:ea typeface="Open Sans" pitchFamily="34" charset="-122"/>
+                <a:cs typeface="Open Sans" pitchFamily="34" charset="-120"/>
+              </a:rPr>
+              <a:t>1. Identify the reporting standard</a:t>
+            </a:r>
+            <a:endParaRPr lang="en-US" sz="1100" dirty="0"/>
+          </a:p>
+          <a:p>
+            <a:pPr marL="0" indent="0">
+              <a:buNone/>
+            </a:pPr>
+            <a:r>
+              <a:rPr lang="en-US" sz="1100" dirty="0">
+                <a:solidFill>
+                  <a:srgbClr val="024731"/>
+                </a:solidFill>
+                <a:latin typeface="Open Sans" pitchFamily="34" charset="0"/>
+                <a:ea typeface="Open Sans" pitchFamily="34" charset="-122"/>
+                <a:cs typeface="Open Sans" pitchFamily="34" charset="-120"/>
+              </a:rPr>
+              <a:t xml:space="preserve">    Record in Cover &amp; Instructions tab</a:t>
+            </a:r>
+            <a:endParaRPr lang="en-US" sz="1100" dirty="0"/>
+          </a:p>
+        </p:txBody>
+      </p:sp>
+      <p:sp>
+        <p:nvSpPr>
+          <p:cNvPr id="8" name="Shape 6"/>
+          <p:cNvSpPr/>
+          <p:nvPr/>
+        </p:nvSpPr>
+        <p:spPr>
+          <a:xfrm>
+            <a:off x="548640" y="2011680"/>
+            <a:ext cx="4114800" cy="502920"/>
+          </a:xfrm>
+          <a:prstGeom prst="rect">
+            <a:avLst/>
+          </a:prstGeom>
+          <a:solidFill>
+            <a:srgbClr val="E6F2EF"/>
+          </a:solidFill>
+          <a:ln/>
+        </p:spPr>
+        <p:txBody>
+          <a:bodyPr/>
+          <a:lstStyle/>
+          <a:p>
+            <a:endParaRPr lang="en-US"/>
+          </a:p>
+        </p:txBody>
+      </p:sp>
+      <p:sp>
+        <p:nvSpPr>
+          <p:cNvPr id="9" name="Text 7"/>
+          <p:cNvSpPr/>
+          <p:nvPr/>
+        </p:nvSpPr>
+        <p:spPr>
+          <a:xfrm>
+            <a:off x="685800" y="2057400"/>
+            <a:ext cx="3840480" cy="411480"/>
+          </a:xfrm>
+          <a:prstGeom prst="rect">
+            <a:avLst/>
+          </a:prstGeom>
+          <a:noFill/>
+          <a:ln/>
+        </p:spPr>
+        <p:txBody>
+          <a:bodyPr wrap="square" rtlCol="0" anchor="ctr"/>
+          <a:lstStyle/>
+          <a:p>
+            <a:pPr marL="0" indent="0">
+              <a:buNone/>
+            </a:pPr>
+            <a:r>
+              <a:rPr lang="en-US" sz="1100" b="1" dirty="0">
+                <a:solidFill>
+                  <a:srgbClr val="024731"/>
+                </a:solidFill>
+                <a:latin typeface="Open Sans" pitchFamily="34" charset="0"/>
+                <a:ea typeface="Open Sans" pitchFamily="34" charset="-122"/>
+                <a:cs typeface="Open Sans" pitchFamily="34" charset="-120"/>
+              </a:rPr>
+              <a:t>2. Check the five high-impact areas</a:t>
+            </a:r>
+            <a:endParaRPr lang="en-US" sz="1100" dirty="0"/>
+          </a:p>
+          <a:p>
+            <a:pPr marL="0" indent="0">
+              <a:buNone/>
+            </a:pPr>
+            <a:r>
+              <a:rPr lang="en-US" sz="1100" dirty="0">
+                <a:solidFill>
+                  <a:srgbClr val="024731"/>
+                </a:solidFill>
+                <a:latin typeface="Open Sans" pitchFamily="34" charset="0"/>
+                <a:ea typeface="Open Sans" pitchFamily="34" charset="-122"/>
+                <a:cs typeface="Open Sans" pitchFamily="34" charset="-120"/>
+              </a:rPr>
+              <a:t xml:space="preserve">    Use the quick-reference checklist</a:t>
+            </a:r>
+            <a:endParaRPr lang="en-US" sz="1100" dirty="0"/>
+          </a:p>
+        </p:txBody>
+      </p:sp>
+      <p:sp>
+        <p:nvSpPr>
+          <p:cNvPr id="10" name="Shape 8"/>
+          <p:cNvSpPr/>
+          <p:nvPr/>
+        </p:nvSpPr>
+        <p:spPr>
+          <a:xfrm>
+            <a:off x="4937760" y="1051560"/>
+            <a:ext cx="3840480" cy="3749040"/>
+          </a:xfrm>
+          <a:prstGeom prst="rect">
+            <a:avLst/>
+          </a:prstGeom>
+          <a:solidFill>
+            <a:srgbClr val="F5F7F6"/>
+          </a:solidFill>
+          <a:ln/>
+          <a:effectLst>
+            <a:outerShdw blurRad="50800" dist="12700" dir="8100000" algn="bl" rotWithShape="0">
+              <a:srgbClr val="000000">
+                <a:alpha val="10000"/>
+              </a:srgbClr>
+            </a:outerShdw>
+          </a:effectLst>
+        </p:spPr>
+        <p:txBody>
+          <a:bodyPr/>
+          <a:lstStyle/>
+          <a:p>
+            <a:endParaRPr lang="en-US"/>
+          </a:p>
+        </p:txBody>
+      </p:sp>
+      <p:sp>
+        <p:nvSpPr>
+          <p:cNvPr id="11" name="Text 9"/>
+          <p:cNvSpPr/>
+          <p:nvPr/>
+        </p:nvSpPr>
+        <p:spPr>
+          <a:xfrm>
+            <a:off x="4946904" y="1143000"/>
+            <a:ext cx="3822192" cy="320040"/>
+          </a:xfrm>
+          <a:prstGeom prst="rect">
+            <a:avLst/>
+          </a:prstGeom>
+          <a:noFill/>
+          <a:ln/>
+        </p:spPr>
+        <p:txBody>
+          <a:bodyPr wrap="square" lIns="0" tIns="0" rIns="0" bIns="0" rtlCol="0" anchor="ctr"/>
+          <a:lstStyle/>
+          <a:p>
+            <a:pPr marL="0" indent="0">
+              <a:buNone/>
+            </a:pPr>
+            <a:r>
+              <a:rPr lang="en-US" sz="1400" b="1" dirty="0">
+                <a:solidFill>
+                  <a:srgbClr val="024731"/>
+                </a:solidFill>
+                <a:latin typeface="Open Sans" pitchFamily="34" charset="0"/>
+                <a:ea typeface="Open Sans" pitchFamily="34" charset="-122"/>
+                <a:cs typeface="Open Sans" pitchFamily="34" charset="-120"/>
+              </a:rPr>
+              <a:t>Steps 3 &amp; 4</a:t>
+            </a:r>
+            <a:endParaRPr lang="en-US" sz="1400" dirty="0"/>
+          </a:p>
+        </p:txBody>
+      </p:sp>
+      <p:sp>
+        <p:nvSpPr>
+          <p:cNvPr id="12" name="Text 10"/>
+          <p:cNvSpPr/>
+          <p:nvPr/>
+        </p:nvSpPr>
+        <p:spPr>
+          <a:xfrm>
+            <a:off x="5120640" y="1417320"/>
+            <a:ext cx="3474720" cy="228600"/>
+          </a:xfrm>
+          <a:prstGeom prst="rect">
+            <a:avLst/>
+          </a:prstGeom>
+          <a:noFill/>
+          <a:ln/>
+        </p:spPr>
+        <p:txBody>
+          <a:bodyPr wrap="square" lIns="0" tIns="0" rIns="0" bIns="0" rtlCol="0" anchor="ctr"/>
+          <a:lstStyle/>
+          <a:p>
+            <a:pPr marL="0" indent="0">
+              <a:buNone/>
+            </a:pPr>
+            <a:r>
+              <a:rPr lang="en-US" sz="900" i="1" dirty="0">
+                <a:solidFill>
+                  <a:srgbClr val="6B7280"/>
+                </a:solidFill>
+                <a:latin typeface="Open Sans" pitchFamily="34" charset="0"/>
+                <a:ea typeface="Open Sans" pitchFamily="34" charset="-122"/>
+                <a:cs typeface="Open Sans" pitchFamily="34" charset="-120"/>
+              </a:rPr>
+              <a:t>Complete in your workbook</a:t>
+            </a:r>
+            <a:endParaRPr lang="en-US" sz="900" dirty="0"/>
+          </a:p>
+        </p:txBody>
+      </p:sp>
+      <p:sp>
+        <p:nvSpPr>
+          <p:cNvPr id="13" name="Shape 11"/>
+          <p:cNvSpPr/>
+          <p:nvPr/>
+        </p:nvSpPr>
+        <p:spPr>
+          <a:xfrm>
+            <a:off x="5212080" y="1783080"/>
+            <a:ext cx="201168" cy="201168"/>
+          </a:xfrm>
+          <a:prstGeom prst="rect">
+            <a:avLst/>
+          </a:prstGeom>
+          <a:solidFill>
+            <a:srgbClr val="FFFFFF"/>
+          </a:solidFill>
+          <a:ln w="19050">
+            <a:solidFill>
+              <a:srgbClr val="024731"/>
+            </a:solidFill>
+            <a:prstDash val="solid"/>
+          </a:ln>
+        </p:spPr>
+        <p:txBody>
+          <a:bodyPr/>
+          <a:lstStyle/>
+          <a:p>
+            <a:endParaRPr lang="en-US"/>
+          </a:p>
+        </p:txBody>
+      </p:sp>
+      <p:sp>
+        <p:nvSpPr>
+          <p:cNvPr id="14" name="Text 12"/>
+          <p:cNvSpPr/>
+          <p:nvPr/>
+        </p:nvSpPr>
+        <p:spPr>
+          <a:xfrm>
+            <a:off x="5532120" y="1764792"/>
+            <a:ext cx="3108960" cy="228600"/>
+          </a:xfrm>
+          <a:prstGeom prst="rect">
+            <a:avLst/>
+          </a:prstGeom>
+          <a:noFill/>
+          <a:ln/>
+        </p:spPr>
+        <p:txBody>
+          <a:bodyPr wrap="square" lIns="0" tIns="0" rIns="0" bIns="0" rtlCol="0" anchor="ctr"/>
+          <a:lstStyle/>
+          <a:p>
+            <a:pPr marL="0" indent="0">
+              <a:buNone/>
+            </a:pPr>
+            <a:r>
+              <a:rPr lang="en-US" sz="1000" dirty="0">
+                <a:solidFill>
+                  <a:srgbClr val="0D0D0D"/>
+                </a:solidFill>
+                <a:latin typeface="Open Sans" pitchFamily="34" charset="0"/>
+                <a:ea typeface="Open Sans" pitchFamily="34" charset="-122"/>
+                <a:cs typeface="Open Sans" pitchFamily="34" charset="-120"/>
+              </a:rPr>
+              <a:t>3. Fill in the GAAP Bridge tab</a:t>
+            </a:r>
+            <a:endParaRPr lang="en-US" sz="1000" dirty="0"/>
+          </a:p>
+        </p:txBody>
+      </p:sp>
+      <p:sp>
+        <p:nvSpPr>
+          <p:cNvPr id="15" name="Shape 13"/>
+          <p:cNvSpPr/>
+          <p:nvPr/>
+        </p:nvSpPr>
+        <p:spPr>
+          <a:xfrm>
+            <a:off x="5212080" y="2130552"/>
+            <a:ext cx="201168" cy="201168"/>
+          </a:xfrm>
+          <a:prstGeom prst="rect">
+            <a:avLst/>
+          </a:prstGeom>
+          <a:solidFill>
+            <a:srgbClr val="FFFFFF"/>
+          </a:solidFill>
+          <a:ln w="19050">
+            <a:solidFill>
+              <a:srgbClr val="024731"/>
+            </a:solidFill>
+            <a:prstDash val="solid"/>
+          </a:ln>
+        </p:spPr>
+        <p:txBody>
+          <a:bodyPr/>
+          <a:lstStyle/>
+          <a:p>
+            <a:endParaRPr lang="en-US"/>
+          </a:p>
+        </p:txBody>
+      </p:sp>
+      <p:sp>
+        <p:nvSpPr>
+          <p:cNvPr id="16" name="Text 14"/>
+          <p:cNvSpPr/>
+          <p:nvPr/>
+        </p:nvSpPr>
+        <p:spPr>
+          <a:xfrm>
+            <a:off x="5532120" y="2112264"/>
+            <a:ext cx="3108960" cy="228600"/>
+          </a:xfrm>
+          <a:prstGeom prst="rect">
+            <a:avLst/>
+          </a:prstGeom>
+          <a:noFill/>
+          <a:ln/>
+        </p:spPr>
+        <p:txBody>
+          <a:bodyPr wrap="square" lIns="0" tIns="0" rIns="0" bIns="0" rtlCol="0" anchor="ctr"/>
+          <a:lstStyle/>
+          <a:p>
+            <a:pPr marL="0" indent="0">
+              <a:buNone/>
+            </a:pPr>
+            <a:r>
+              <a:rPr lang="en-US" sz="1000" dirty="0">
+                <a:solidFill>
+                  <a:srgbClr val="0D0D0D"/>
+                </a:solidFill>
+                <a:latin typeface="Open Sans" pitchFamily="34" charset="0"/>
+                <a:ea typeface="Open Sans" pitchFamily="34" charset="-122"/>
+                <a:cs typeface="Open Sans" pitchFamily="34" charset="-120"/>
+              </a:rPr>
+              <a:t>Copy from models/templates/</a:t>
+            </a:r>
+            <a:endParaRPr lang="en-US" sz="1000" dirty="0"/>
+          </a:p>
+        </p:txBody>
+      </p:sp>
+      <p:sp>
+        <p:nvSpPr>
+          <p:cNvPr id="17" name="Shape 15"/>
+          <p:cNvSpPr/>
+          <p:nvPr/>
+        </p:nvSpPr>
+        <p:spPr>
+          <a:xfrm>
+            <a:off x="5212080" y="2478024"/>
+            <a:ext cx="201168" cy="201168"/>
+          </a:xfrm>
+          <a:prstGeom prst="rect">
+            <a:avLst/>
+          </a:prstGeom>
+          <a:solidFill>
+            <a:srgbClr val="FFFFFF"/>
+          </a:solidFill>
+          <a:ln w="19050">
+            <a:solidFill>
+              <a:srgbClr val="024731"/>
+            </a:solidFill>
+            <a:prstDash val="solid"/>
+          </a:ln>
+        </p:spPr>
+        <p:txBody>
+          <a:bodyPr/>
+          <a:lstStyle/>
+          <a:p>
+            <a:endParaRPr lang="en-US"/>
+          </a:p>
+        </p:txBody>
+      </p:sp>
+      <p:sp>
+        <p:nvSpPr>
+          <p:cNvPr id="18" name="Text 16"/>
+          <p:cNvSpPr/>
+          <p:nvPr/>
+        </p:nvSpPr>
+        <p:spPr>
+          <a:xfrm>
+            <a:off x="5532120" y="2459736"/>
+            <a:ext cx="3108960" cy="228600"/>
+          </a:xfrm>
+          <a:prstGeom prst="rect">
+            <a:avLst/>
+          </a:prstGeom>
+          <a:noFill/>
+          <a:ln/>
+        </p:spPr>
+        <p:txBody>
+          <a:bodyPr wrap="square" lIns="0" tIns="0" rIns="0" bIns="0" rtlCol="0" anchor="ctr"/>
+          <a:lstStyle/>
+          <a:p>
+            <a:pPr marL="0" indent="0">
+              <a:buNone/>
+            </a:pPr>
+            <a:r>
+              <a:rPr lang="en-US" sz="1000" dirty="0">
+                <a:solidFill>
+                  <a:srgbClr val="0D0D0D"/>
+                </a:solidFill>
+                <a:latin typeface="Open Sans" pitchFamily="34" charset="0"/>
+                <a:ea typeface="Open Sans" pitchFamily="34" charset="-122"/>
+                <a:cs typeface="Open Sans" pitchFamily="34" charset="-120"/>
+              </a:rPr>
+              <a:t>gaap-bridge-template.xlsx</a:t>
+            </a:r>
+            <a:endParaRPr lang="en-US" sz="1000" dirty="0"/>
+          </a:p>
+        </p:txBody>
+      </p:sp>
+      <p:sp>
+        <p:nvSpPr>
+          <p:cNvPr id="19" name="Shape 17"/>
+          <p:cNvSpPr/>
+          <p:nvPr/>
+        </p:nvSpPr>
+        <p:spPr>
+          <a:xfrm>
+            <a:off x="5212080" y="2825496"/>
+            <a:ext cx="201168" cy="201168"/>
+          </a:xfrm>
+          <a:prstGeom prst="rect">
+            <a:avLst/>
+          </a:prstGeom>
+          <a:solidFill>
+            <a:srgbClr val="FFFFFF"/>
+          </a:solidFill>
+          <a:ln w="19050">
+            <a:solidFill>
+              <a:srgbClr val="024731"/>
+            </a:solidFill>
+            <a:prstDash val="solid"/>
+          </a:ln>
+        </p:spPr>
+        <p:txBody>
+          <a:bodyPr/>
+          <a:lstStyle/>
+          <a:p>
+            <a:endParaRPr lang="en-US"/>
+          </a:p>
+        </p:txBody>
+      </p:sp>
+      <p:sp>
+        <p:nvSpPr>
+          <p:cNvPr id="20" name="Text 18"/>
+          <p:cNvSpPr/>
+          <p:nvPr/>
+        </p:nvSpPr>
+        <p:spPr>
+          <a:xfrm>
+            <a:off x="5532120" y="2807208"/>
+            <a:ext cx="3108960" cy="228600"/>
+          </a:xfrm>
+          <a:prstGeom prst="rect">
+            <a:avLst/>
+          </a:prstGeom>
+          <a:noFill/>
+          <a:ln/>
+        </p:spPr>
+        <p:txBody>
+          <a:bodyPr wrap="square" lIns="0" tIns="0" rIns="0" bIns="0" rtlCol="0" anchor="ctr"/>
+          <a:lstStyle/>
+          <a:p>
+            <a:pPr marL="0" indent="0">
+              <a:buNone/>
+            </a:pPr>
+            <a:r>
+              <a:rPr lang="en-US" sz="1000" dirty="0">
+                <a:solidFill>
+                  <a:srgbClr val="0D0D0D"/>
+                </a:solidFill>
+                <a:latin typeface="Open Sans" pitchFamily="34" charset="0"/>
+                <a:ea typeface="Open Sans" pitchFamily="34" charset="-122"/>
+                <a:cs typeface="Open Sans" pitchFamily="34" charset="-120"/>
+              </a:rPr>
+              <a:t>4. Flag affected ratios</a:t>
+            </a:r>
+            <a:endParaRPr lang="en-US" sz="1000" dirty="0"/>
+          </a:p>
+        </p:txBody>
+      </p:sp>
+      <p:sp>
+        <p:nvSpPr>
+          <p:cNvPr id="21" name="Shape 19"/>
+          <p:cNvSpPr/>
+          <p:nvPr/>
+        </p:nvSpPr>
+        <p:spPr>
+          <a:xfrm>
+            <a:off x="5212080" y="3172968"/>
+            <a:ext cx="201168" cy="201168"/>
+          </a:xfrm>
+          <a:prstGeom prst="rect">
+            <a:avLst/>
+          </a:prstGeom>
+          <a:solidFill>
+            <a:srgbClr val="FFFFFF"/>
+          </a:solidFill>
+          <a:ln w="19050">
+            <a:solidFill>
+              <a:srgbClr val="024731"/>
+            </a:solidFill>
+            <a:prstDash val="solid"/>
+          </a:ln>
+        </p:spPr>
+        <p:txBody>
+          <a:bodyPr/>
+          <a:lstStyle/>
+          <a:p>
+            <a:endParaRPr lang="en-US"/>
+          </a:p>
+        </p:txBody>
+      </p:sp>
+      <p:sp>
+        <p:nvSpPr>
+          <p:cNvPr id="22" name="Text 20"/>
+          <p:cNvSpPr/>
+          <p:nvPr/>
+        </p:nvSpPr>
+        <p:spPr>
+          <a:xfrm>
+            <a:off x="5532120" y="3154680"/>
+            <a:ext cx="3108960" cy="228600"/>
+          </a:xfrm>
+          <a:prstGeom prst="rect">
+            <a:avLst/>
+          </a:prstGeom>
+          <a:noFill/>
+          <a:ln/>
+        </p:spPr>
+        <p:txBody>
+          <a:bodyPr wrap="square" lIns="0" tIns="0" rIns="0" bIns="0" rtlCol="0" anchor="ctr"/>
+          <a:lstStyle/>
+          <a:p>
+            <a:pPr marL="0" indent="0">
+              <a:buNone/>
+            </a:pPr>
+            <a:r>
+              <a:rPr lang="en-US" sz="1000" dirty="0">
+                <a:solidFill>
+                  <a:srgbClr val="0D0D0D"/>
+                </a:solidFill>
+                <a:latin typeface="Open Sans" pitchFamily="34" charset="0"/>
+                <a:ea typeface="Open Sans" pitchFamily="34" charset="-122"/>
+                <a:cs typeface="Open Sans" pitchFamily="34" charset="-120"/>
+              </a:rPr>
+              <a:t>Add cell comments referencing</a:t>
+            </a:r>
+            <a:endParaRPr lang="en-US" sz="1000" dirty="0"/>
+          </a:p>
+        </p:txBody>
+      </p:sp>
+      <p:sp>
+        <p:nvSpPr>
+          <p:cNvPr id="23" name="Shape 21"/>
+          <p:cNvSpPr/>
+          <p:nvPr/>
+        </p:nvSpPr>
+        <p:spPr>
+          <a:xfrm>
+            <a:off x="5212080" y="3520440"/>
+            <a:ext cx="201168" cy="201168"/>
+          </a:xfrm>
+          <a:prstGeom prst="rect">
+            <a:avLst/>
+          </a:prstGeom>
+          <a:solidFill>
+            <a:srgbClr val="FFFFFF"/>
+          </a:solidFill>
+          <a:ln w="19050">
+            <a:solidFill>
+              <a:srgbClr val="024731"/>
+            </a:solidFill>
+            <a:prstDash val="solid"/>
+          </a:ln>
+        </p:spPr>
+        <p:txBody>
+          <a:bodyPr/>
+          <a:lstStyle/>
+          <a:p>
+            <a:endParaRPr lang="en-US"/>
+          </a:p>
+        </p:txBody>
+      </p:sp>
+      <p:sp>
+        <p:nvSpPr>
+          <p:cNvPr id="24" name="Text 22"/>
+          <p:cNvSpPr/>
+          <p:nvPr/>
+        </p:nvSpPr>
+        <p:spPr>
+          <a:xfrm>
+            <a:off x="5532120" y="3502152"/>
+            <a:ext cx="3108960" cy="228600"/>
+          </a:xfrm>
+          <a:prstGeom prst="rect">
+            <a:avLst/>
+          </a:prstGeom>
+          <a:noFill/>
+          <a:ln/>
+        </p:spPr>
+        <p:txBody>
+          <a:bodyPr wrap="square" lIns="0" tIns="0" rIns="0" bIns="0" rtlCol="0" anchor="ctr"/>
+          <a:lstStyle/>
+          <a:p>
+            <a:pPr marL="0" indent="0">
+              <a:buNone/>
+            </a:pPr>
+            <a:r>
+              <a:rPr lang="en-US" sz="1000" dirty="0">
+                <a:solidFill>
+                  <a:srgbClr val="0D0D0D"/>
+                </a:solidFill>
+                <a:latin typeface="Open Sans" pitchFamily="34" charset="0"/>
+                <a:ea typeface="Open Sans" pitchFamily="34" charset="-122"/>
+                <a:cs typeface="Open Sans" pitchFamily="34" charset="-120"/>
+              </a:rPr>
+              <a:t>GAAP Bridge rows on Ratios tab</a:t>
+            </a:r>
+            <a:endParaRPr lang="en-US" sz="1000" dirty="0"/>
+          </a:p>
+        </p:txBody>
+      </p:sp>
+      <p:sp>
+        <p:nvSpPr>
+          <p:cNvPr id="29" name="Shape 27"/>
+          <p:cNvSpPr/>
+          <p:nvPr/>
+        </p:nvSpPr>
+        <p:spPr>
+          <a:xfrm>
+            <a:off x="548640" y="4434840"/>
+            <a:ext cx="4114800" cy="457200"/>
+          </a:xfrm>
+          <a:prstGeom prst="rect">
+            <a:avLst/>
+          </a:prstGeom>
+          <a:solidFill>
+            <a:srgbClr val="024731"/>
+          </a:solidFill>
+          <a:ln/>
+        </p:spPr>
+        <p:txBody>
+          <a:bodyPr/>
+          <a:lstStyle/>
+          <a:p>
+            <a:endParaRPr lang="en-US"/>
+          </a:p>
+        </p:txBody>
+      </p:sp>
+      <p:sp>
+        <p:nvSpPr>
+          <p:cNvPr id="30" name="Text 28"/>
+          <p:cNvSpPr/>
+          <p:nvPr/>
+        </p:nvSpPr>
+        <p:spPr>
+          <a:xfrm>
+            <a:off x="685800" y="4453128"/>
+            <a:ext cx="3840480" cy="411480"/>
+          </a:xfrm>
+          <a:prstGeom prst="rect">
+            <a:avLst/>
+          </a:prstGeom>
+          <a:noFill/>
+          <a:ln/>
+        </p:spPr>
+        <p:txBody>
+          <a:bodyPr wrap="square" rtlCol="0" anchor="ctr"/>
+          <a:lstStyle/>
+          <a:p>
+            <a:pPr marL="0" indent="0">
+              <a:buNone/>
+            </a:pPr>
+            <a:r>
+              <a:rPr lang="en-US" sz="1000" dirty="0">
+                <a:solidFill>
+                  <a:srgbClr val="FFFFFF"/>
+                </a:solidFill>
+                <a:latin typeface="Open Sans" pitchFamily="34" charset="0"/>
+                <a:ea typeface="Open Sans" pitchFamily="34" charset="-122"/>
+                <a:cs typeface="Open Sans" pitchFamily="34" charset="-120"/>
+              </a:rPr>
+              <a:t>Do NOT restate your financials. The GAAP Bridge is a disclosure exercise showing you understand the differences.</a:t>
+            </a:r>
+            <a:endParaRPr lang="en-US" sz="1000" dirty="0"/>
+          </a:p>
+        </p:txBody>
+      </p:sp>
+    </p:spTree>
+  </p:cSld>
+  <p:clrMapOvr>
+    <a:masterClrMapping/>
+  </p:clrMapOvr>
+</p:sld>
+</file>
+
+<file path=ppt/slides/slide55.xml><?xml version="1.0" encoding="utf-8"?>
+<p:sld xmlns:a="http://schemas.openxmlformats.org/drawingml/2006/main" xmlns:r="http://schemas.openxmlformats.org/officeDocument/2006/relationships" xmlns:p="http://schemas.openxmlformats.org/presentationml/2006/main">
+  <p:cSld name="Slide 8">
+    <p:bg>
+      <p:bgPr>
+        <a:solidFill>
+          <a:srgbClr val="FFFFFF"/>
+        </a:solidFill>
+        <a:effectLst/>
+      </p:bgPr>
+    </p:bg>
+    <p:spTree>
+      <p:nvGrpSpPr>
+        <p:cNvPr id="1" name=""/>
+        <p:cNvGrpSpPr/>
+        <p:nvPr/>
+      </p:nvGrpSpPr>
+      <p:grpSpPr>
+        <a:xfrm>
+          <a:off x="0" y="0"/>
+          <a:ext cx="0" cy="0"/>
+          <a:chOff x="0" y="0"/>
+          <a:chExt cx="0" cy="0"/>
+        </a:xfrm>
+      </p:grpSpPr>
+      <p:sp>
+        <p:nvSpPr>
+          <p:cNvPr id="2" name="Shape 0"/>
+          <p:cNvSpPr/>
+          <p:nvPr/>
+        </p:nvSpPr>
+        <p:spPr>
+          <a:xfrm>
+            <a:off x="0" y="0"/>
+            <a:ext cx="9144000" cy="822960"/>
+          </a:xfrm>
+          <a:prstGeom prst="rect">
+            <a:avLst/>
+          </a:prstGeom>
+          <a:solidFill>
+            <a:srgbClr val="024731"/>
+          </a:solidFill>
+          <a:ln/>
+        </p:spPr>
+        <p:txBody>
+          <a:bodyPr/>
+          <a:lstStyle/>
+          <a:p>
+            <a:endParaRPr lang="en-US"/>
+          </a:p>
+        </p:txBody>
+      </p:sp>
+      <p:sp>
+        <p:nvSpPr>
+          <p:cNvPr id="3" name="Text 1"/>
+          <p:cNvSpPr/>
+          <p:nvPr/>
+        </p:nvSpPr>
+        <p:spPr>
+          <a:xfrm>
+            <a:off x="548640" y="137160"/>
+            <a:ext cx="7315200" cy="274320"/>
+          </a:xfrm>
+          <a:prstGeom prst="rect">
+            <a:avLst/>
+          </a:prstGeom>
+          <a:noFill/>
+          <a:ln/>
+        </p:spPr>
+        <p:txBody>
+          <a:bodyPr wrap="square" lIns="0" tIns="0" rIns="0" bIns="0" rtlCol="0" anchor="ctr"/>
+          <a:lstStyle/>
+          <a:p>
+            <a:pPr marL="0" indent="0">
+              <a:buNone/>
+            </a:pPr>
+            <a:r>
+              <a:rPr lang="en-US" sz="2000" b="1" dirty="0">
+                <a:solidFill>
+                  <a:srgbClr val="FFFFFF"/>
+                </a:solidFill>
+                <a:latin typeface="Open Sans" pitchFamily="34" charset="0"/>
+                <a:ea typeface="Open Sans" pitchFamily="34" charset="-122"/>
+                <a:cs typeface="Open Sans" pitchFamily="34" charset="-120"/>
+              </a:rPr>
+              <a:t>Resources &amp; Where to Find Them</a:t>
+            </a:r>
+            <a:endParaRPr lang="en-US" sz="2000" dirty="0"/>
+          </a:p>
+        </p:txBody>
+      </p:sp>
+      <p:sp>
+        <p:nvSpPr>
+          <p:cNvPr id="4" name="Text 2"/>
+          <p:cNvSpPr/>
+          <p:nvPr/>
+        </p:nvSpPr>
+        <p:spPr>
+          <a:xfrm>
+            <a:off x="548640" y="429768"/>
+            <a:ext cx="7315200" cy="228600"/>
+          </a:xfrm>
+          <a:prstGeom prst="rect">
+            <a:avLst/>
+          </a:prstGeom>
+          <a:noFill/>
+          <a:ln/>
+        </p:spPr>
+        <p:txBody>
+          <a:bodyPr wrap="square" lIns="0" tIns="0" rIns="0" bIns="0" rtlCol="0" anchor="ctr"/>
+          <a:lstStyle/>
+          <a:p>
+            <a:pPr marL="0" indent="0">
+              <a:buNone/>
+            </a:pPr>
+            <a:r>
+              <a:rPr lang="en-US" sz="1100" dirty="0">
+                <a:solidFill>
+                  <a:srgbClr val="B8DDD1"/>
+                </a:solidFill>
+                <a:latin typeface="Open Sans" pitchFamily="34" charset="0"/>
+                <a:ea typeface="Open Sans" pitchFamily="34" charset="-122"/>
+                <a:cs typeface="Open Sans" pitchFamily="34" charset="-120"/>
+              </a:rPr>
+              <a:t>Appendix C  |  Three documents in the course repo support your GAAP conversion work</a:t>
+            </a:r>
+            <a:endParaRPr lang="en-US" sz="1100" dirty="0"/>
+          </a:p>
+        </p:txBody>
+      </p:sp>
+      <p:sp>
+        <p:nvSpPr>
+          <p:cNvPr id="5" name="Text 3"/>
+          <p:cNvSpPr/>
+          <p:nvPr/>
+        </p:nvSpPr>
+        <p:spPr>
+          <a:xfrm>
+            <a:off x="548640" y="1051560"/>
+            <a:ext cx="4114800" cy="274320"/>
+          </a:xfrm>
+          <a:prstGeom prst="rect">
+            <a:avLst/>
+          </a:prstGeom>
+          <a:noFill/>
+          <a:ln/>
+        </p:spPr>
+        <p:txBody>
+          <a:bodyPr wrap="square" lIns="0" tIns="0" rIns="0" bIns="0" rtlCol="0" anchor="ctr"/>
+          <a:lstStyle/>
+          <a:p>
+            <a:pPr marL="0" indent="0">
+              <a:buNone/>
+            </a:pPr>
+            <a:r>
+              <a:rPr lang="en-US" sz="1400" b="1" dirty="0">
+                <a:solidFill>
+                  <a:srgbClr val="024731"/>
+                </a:solidFill>
+                <a:latin typeface="Open Sans" pitchFamily="34" charset="0"/>
+                <a:ea typeface="Open Sans" pitchFamily="34" charset="-122"/>
+                <a:cs typeface="Open Sans" pitchFamily="34" charset="-120"/>
+              </a:rPr>
+              <a:t>Documents in the Course Repo</a:t>
+            </a:r>
+            <a:endParaRPr lang="en-US" sz="1400" dirty="0"/>
+          </a:p>
+        </p:txBody>
+      </p:sp>
+      <p:sp>
+        <p:nvSpPr>
+          <p:cNvPr id="6" name="Shape 4"/>
+          <p:cNvSpPr/>
+          <p:nvPr/>
+        </p:nvSpPr>
+        <p:spPr>
+          <a:xfrm>
+            <a:off x="548640" y="1417320"/>
+            <a:ext cx="4114800" cy="502920"/>
+          </a:xfrm>
+          <a:prstGeom prst="rect">
+            <a:avLst/>
+          </a:prstGeom>
+          <a:solidFill>
+            <a:srgbClr val="E6F2EF"/>
+          </a:solidFill>
+          <a:ln/>
+        </p:spPr>
+        <p:txBody>
+          <a:bodyPr/>
+          <a:lstStyle/>
+          <a:p>
+            <a:endParaRPr lang="en-US"/>
+          </a:p>
+        </p:txBody>
+      </p:sp>
+      <p:sp>
+        <p:nvSpPr>
+          <p:cNvPr id="7" name="Text 5"/>
+          <p:cNvSpPr/>
+          <p:nvPr/>
+        </p:nvSpPr>
+        <p:spPr>
+          <a:xfrm>
+            <a:off x="685800" y="1463040"/>
+            <a:ext cx="3840480" cy="411480"/>
+          </a:xfrm>
+          <a:prstGeom prst="rect">
+            <a:avLst/>
+          </a:prstGeom>
+          <a:noFill/>
+          <a:ln/>
+        </p:spPr>
+        <p:txBody>
+          <a:bodyPr wrap="square" rtlCol="0" anchor="ctr"/>
+          <a:lstStyle/>
+          <a:p>
+            <a:pPr marL="0" indent="0">
+              <a:buNone/>
+            </a:pPr>
+            <a:r>
+              <a:rPr lang="en-US" sz="1100" b="1" dirty="0">
+                <a:solidFill>
+                  <a:srgbClr val="024731"/>
+                </a:solidFill>
+                <a:latin typeface="Open Sans" pitchFamily="34" charset="0"/>
+                <a:ea typeface="Open Sans" pitchFamily="34" charset="-122"/>
+                <a:cs typeface="Open Sans" pitchFamily="34" charset="-120"/>
+              </a:rPr>
+              <a:t>Quick-Reference (start here)</a:t>
+            </a:r>
+            <a:endParaRPr lang="en-US" sz="1100" dirty="0"/>
+          </a:p>
+          <a:p>
+            <a:pPr marL="0" indent="0">
+              <a:buNone/>
+            </a:pPr>
+            <a:r>
+              <a:rPr lang="en-US" sz="1100" dirty="0">
+                <a:solidFill>
+                  <a:srgbClr val="024731"/>
+                </a:solidFill>
+                <a:latin typeface="Open Sans" pitchFamily="34" charset="0"/>
+                <a:ea typeface="Open Sans" pitchFamily="34" charset="-122"/>
+                <a:cs typeface="Open Sans" pitchFamily="34" charset="-120"/>
+              </a:rPr>
+              <a:t xml:space="preserve">    docs/templates/gaap-conversion-quickref.md</a:t>
+            </a:r>
+            <a:endParaRPr lang="en-US" sz="1100" dirty="0"/>
+          </a:p>
+        </p:txBody>
+      </p:sp>
+      <p:sp>
+        <p:nvSpPr>
+          <p:cNvPr id="8" name="Shape 6"/>
+          <p:cNvSpPr/>
+          <p:nvPr/>
+        </p:nvSpPr>
+        <p:spPr>
+          <a:xfrm>
+            <a:off x="548640" y="2011680"/>
+            <a:ext cx="4114800" cy="502920"/>
+          </a:xfrm>
+          <a:prstGeom prst="rect">
+            <a:avLst/>
+          </a:prstGeom>
+          <a:solidFill>
+            <a:srgbClr val="E6F2EF"/>
+          </a:solidFill>
+          <a:ln/>
+        </p:spPr>
+        <p:txBody>
+          <a:bodyPr/>
+          <a:lstStyle/>
+          <a:p>
+            <a:endParaRPr lang="en-US"/>
+          </a:p>
+        </p:txBody>
+      </p:sp>
+      <p:sp>
+        <p:nvSpPr>
+          <p:cNvPr id="9" name="Text 7"/>
+          <p:cNvSpPr/>
+          <p:nvPr/>
+        </p:nvSpPr>
+        <p:spPr>
+          <a:xfrm>
+            <a:off x="685800" y="2057400"/>
+            <a:ext cx="3840480" cy="411480"/>
+          </a:xfrm>
+          <a:prstGeom prst="rect">
+            <a:avLst/>
+          </a:prstGeom>
+          <a:noFill/>
+          <a:ln/>
+        </p:spPr>
+        <p:txBody>
+          <a:bodyPr wrap="square" rtlCol="0" anchor="ctr"/>
+          <a:lstStyle/>
+          <a:p>
+            <a:pPr marL="0" indent="0">
+              <a:buNone/>
+            </a:pPr>
+            <a:r>
+              <a:rPr lang="en-US" sz="1100" b="1" dirty="0">
+                <a:solidFill>
+                  <a:srgbClr val="024731"/>
+                </a:solidFill>
+                <a:latin typeface="Open Sans" pitchFamily="34" charset="0"/>
+                <a:ea typeface="Open Sans" pitchFamily="34" charset="-122"/>
+                <a:cs typeface="Open Sans" pitchFamily="34" charset="-120"/>
+              </a:rPr>
+              <a:t>GAAP Bridge Template (.xlsx)</a:t>
+            </a:r>
+            <a:endParaRPr lang="en-US" sz="1100" dirty="0"/>
+          </a:p>
+          <a:p>
+            <a:pPr marL="0" indent="0">
+              <a:buNone/>
+            </a:pPr>
+            <a:r>
+              <a:rPr lang="en-US" sz="1100" dirty="0">
+                <a:solidFill>
+                  <a:srgbClr val="024731"/>
+                </a:solidFill>
+                <a:latin typeface="Open Sans" pitchFamily="34" charset="0"/>
+                <a:ea typeface="Open Sans" pitchFamily="34" charset="-122"/>
+                <a:cs typeface="Open Sans" pitchFamily="34" charset="-120"/>
+              </a:rPr>
+              <a:t xml:space="preserve">    models/templates/gaap-bridge-template.xlsx</a:t>
+            </a:r>
+            <a:endParaRPr lang="en-US" sz="1100" dirty="0"/>
+          </a:p>
+        </p:txBody>
+      </p:sp>
+      <p:sp>
+        <p:nvSpPr>
+          <p:cNvPr id="10" name="Shape 8"/>
+          <p:cNvSpPr/>
+          <p:nvPr/>
+        </p:nvSpPr>
+        <p:spPr>
+          <a:xfrm>
+            <a:off x="4937760" y="1051560"/>
+            <a:ext cx="3840480" cy="3749040"/>
+          </a:xfrm>
+          <a:prstGeom prst="rect">
+            <a:avLst/>
+          </a:prstGeom>
+          <a:solidFill>
+            <a:srgbClr val="F5F7F6"/>
+          </a:solidFill>
+          <a:ln/>
+          <a:effectLst>
+            <a:outerShdw blurRad="50800" dist="12700" dir="8100000" algn="bl" rotWithShape="0">
+              <a:srgbClr val="000000">
+                <a:alpha val="10000"/>
+              </a:srgbClr>
+            </a:outerShdw>
+          </a:effectLst>
+        </p:spPr>
+        <p:txBody>
+          <a:bodyPr/>
+          <a:lstStyle/>
+          <a:p>
+            <a:endParaRPr lang="en-US"/>
+          </a:p>
+        </p:txBody>
+      </p:sp>
+      <p:sp>
+        <p:nvSpPr>
+          <p:cNvPr id="11" name="Text 9"/>
+          <p:cNvSpPr/>
+          <p:nvPr/>
+        </p:nvSpPr>
+        <p:spPr>
+          <a:xfrm>
+            <a:off x="4946904" y="1143000"/>
+            <a:ext cx="3822192" cy="320040"/>
+          </a:xfrm>
+          <a:prstGeom prst="rect">
+            <a:avLst/>
+          </a:prstGeom>
+          <a:noFill/>
+          <a:ln/>
+        </p:spPr>
+        <p:txBody>
+          <a:bodyPr wrap="square" lIns="0" tIns="0" rIns="0" bIns="0" rtlCol="0" anchor="ctr"/>
+          <a:lstStyle/>
+          <a:p>
+            <a:pPr marL="0" indent="0">
+              <a:buNone/>
+            </a:pPr>
+            <a:r>
+              <a:rPr lang="en-US" sz="1400" b="1" dirty="0">
+                <a:solidFill>
+                  <a:srgbClr val="024731"/>
+                </a:solidFill>
+                <a:latin typeface="Open Sans" pitchFamily="34" charset="0"/>
+                <a:ea typeface="Open Sans" pitchFamily="34" charset="-122"/>
+                <a:cs typeface="Open Sans" pitchFamily="34" charset="-120"/>
+              </a:rPr>
+              <a:t>Full Decision Memo (optional)</a:t>
+            </a:r>
+            <a:endParaRPr lang="en-US" sz="1400" dirty="0"/>
+          </a:p>
+        </p:txBody>
+      </p:sp>
+      <p:sp>
+        <p:nvSpPr>
+          <p:cNvPr id="12" name="Text 10"/>
+          <p:cNvSpPr/>
+          <p:nvPr/>
+        </p:nvSpPr>
+        <p:spPr>
+          <a:xfrm>
+            <a:off x="5120640" y="1417320"/>
+            <a:ext cx="3474720" cy="228600"/>
+          </a:xfrm>
+          <a:prstGeom prst="rect">
+            <a:avLst/>
+          </a:prstGeom>
+          <a:noFill/>
+          <a:ln/>
+        </p:spPr>
+        <p:txBody>
+          <a:bodyPr wrap="square" lIns="0" tIns="0" rIns="0" bIns="0" rtlCol="0" anchor="ctr"/>
+          <a:lstStyle/>
+          <a:p>
+            <a:pPr marL="0" indent="0">
+              <a:buNone/>
+            </a:pPr>
+            <a:r>
+              <a:rPr lang="en-US" sz="900" i="1" dirty="0">
+                <a:solidFill>
+                  <a:srgbClr val="6B7280"/>
+                </a:solidFill>
+                <a:latin typeface="Open Sans" pitchFamily="34" charset="0"/>
+                <a:ea typeface="Open Sans" pitchFamily="34" charset="-122"/>
+                <a:cs typeface="Open Sans" pitchFamily="34" charset="-120"/>
+              </a:rPr>
+              <a:t>For deeper reading, not required</a:t>
+            </a:r>
+            <a:endParaRPr lang="en-US" sz="900" dirty="0"/>
+          </a:p>
+        </p:txBody>
+      </p:sp>
+      <p:sp>
+        <p:nvSpPr>
+          <p:cNvPr id="13" name="Shape 11"/>
+          <p:cNvSpPr/>
+          <p:nvPr/>
+        </p:nvSpPr>
+        <p:spPr>
+          <a:xfrm>
+            <a:off x="5212080" y="1783080"/>
+            <a:ext cx="201168" cy="201168"/>
+          </a:xfrm>
+          <a:prstGeom prst="rect">
+            <a:avLst/>
+          </a:prstGeom>
+          <a:solidFill>
+            <a:srgbClr val="FFFFFF"/>
+          </a:solidFill>
+          <a:ln w="19050">
+            <a:solidFill>
+              <a:srgbClr val="024731"/>
+            </a:solidFill>
+            <a:prstDash val="solid"/>
+          </a:ln>
+        </p:spPr>
+        <p:txBody>
+          <a:bodyPr/>
+          <a:lstStyle/>
+          <a:p>
+            <a:endParaRPr lang="en-US"/>
+          </a:p>
+        </p:txBody>
+      </p:sp>
+      <p:sp>
+        <p:nvSpPr>
+          <p:cNvPr id="14" name="Text 12"/>
+          <p:cNvSpPr/>
+          <p:nvPr/>
+        </p:nvSpPr>
+        <p:spPr>
+          <a:xfrm>
+            <a:off x="5532120" y="1764792"/>
+            <a:ext cx="3108960" cy="228600"/>
+          </a:xfrm>
+          <a:prstGeom prst="rect">
+            <a:avLst/>
+          </a:prstGeom>
+          <a:noFill/>
+          <a:ln/>
+        </p:spPr>
+        <p:txBody>
+          <a:bodyPr wrap="square" lIns="0" tIns="0" rIns="0" bIns="0" rtlCol="0" anchor="ctr"/>
+          <a:lstStyle/>
+          <a:p>
+            <a:pPr marL="0" indent="0">
+              <a:buNone/>
+            </a:pPr>
+            <a:r>
+              <a:rPr lang="en-US" sz="1000" dirty="0">
+                <a:solidFill>
+                  <a:srgbClr val="0D0D0D"/>
+                </a:solidFill>
+                <a:latin typeface="Open Sans" pitchFamily="34" charset="0"/>
+                <a:ea typeface="Open Sans" pitchFamily="34" charset="-122"/>
+                <a:cs typeface="Open Sans" pitchFamily="34" charset="-120"/>
+              </a:rPr>
+              <a:t>7 frameworks surveyed (US GAAP,</a:t>
+            </a:r>
+            <a:endParaRPr lang="en-US" sz="1000" dirty="0"/>
+          </a:p>
+        </p:txBody>
+      </p:sp>
+      <p:sp>
+        <p:nvSpPr>
+          <p:cNvPr id="15" name="Shape 13"/>
+          <p:cNvSpPr/>
+          <p:nvPr/>
+        </p:nvSpPr>
+        <p:spPr>
+          <a:xfrm>
+            <a:off x="5212080" y="2130552"/>
+            <a:ext cx="201168" cy="201168"/>
+          </a:xfrm>
+          <a:prstGeom prst="rect">
+            <a:avLst/>
+          </a:prstGeom>
+          <a:solidFill>
+            <a:srgbClr val="FFFFFF"/>
+          </a:solidFill>
+          <a:ln w="19050">
+            <a:solidFill>
+              <a:srgbClr val="024731"/>
+            </a:solidFill>
+            <a:prstDash val="solid"/>
+          </a:ln>
+        </p:spPr>
+        <p:txBody>
+          <a:bodyPr/>
+          <a:lstStyle/>
+          <a:p>
+            <a:endParaRPr lang="en-US"/>
+          </a:p>
+        </p:txBody>
+      </p:sp>
+      <p:sp>
+        <p:nvSpPr>
+          <p:cNvPr id="16" name="Text 14"/>
+          <p:cNvSpPr/>
+          <p:nvPr/>
+        </p:nvSpPr>
+        <p:spPr>
+          <a:xfrm>
+            <a:off x="5532120" y="2112264"/>
+            <a:ext cx="3108960" cy="228600"/>
+          </a:xfrm>
+          <a:prstGeom prst="rect">
+            <a:avLst/>
+          </a:prstGeom>
+          <a:noFill/>
+          <a:ln/>
+        </p:spPr>
+        <p:txBody>
+          <a:bodyPr wrap="square" lIns="0" tIns="0" rIns="0" bIns="0" rtlCol="0" anchor="ctr"/>
+          <a:lstStyle/>
+          <a:p>
+            <a:pPr marL="0" indent="0">
+              <a:buNone/>
+            </a:pPr>
+            <a:r>
+              <a:rPr lang="en-US" sz="1000" dirty="0">
+                <a:solidFill>
+                  <a:srgbClr val="0D0D0D"/>
+                </a:solidFill>
+                <a:latin typeface="Open Sans" pitchFamily="34" charset="0"/>
+                <a:ea typeface="Open Sans" pitchFamily="34" charset="-122"/>
+                <a:cs typeface="Open Sans" pitchFamily="34" charset="-120"/>
+              </a:rPr>
+              <a:t>IFRS, VAS, CAS, JGAAP, Ind AS, SFRS)</a:t>
+            </a:r>
+            <a:endParaRPr lang="en-US" sz="1000" dirty="0"/>
+          </a:p>
+        </p:txBody>
+      </p:sp>
+      <p:sp>
+        <p:nvSpPr>
+          <p:cNvPr id="17" name="Shape 15"/>
+          <p:cNvSpPr/>
+          <p:nvPr/>
+        </p:nvSpPr>
+        <p:spPr>
+          <a:xfrm>
+            <a:off x="5212080" y="2478024"/>
+            <a:ext cx="201168" cy="201168"/>
+          </a:xfrm>
+          <a:prstGeom prst="rect">
+            <a:avLst/>
+          </a:prstGeom>
+          <a:solidFill>
+            <a:srgbClr val="FFFFFF"/>
+          </a:solidFill>
+          <a:ln w="19050">
+            <a:solidFill>
+              <a:srgbClr val="024731"/>
+            </a:solidFill>
+            <a:prstDash val="solid"/>
+          </a:ln>
+        </p:spPr>
+        <p:txBody>
+          <a:bodyPr/>
+          <a:lstStyle/>
+          <a:p>
+            <a:endParaRPr lang="en-US"/>
+          </a:p>
+        </p:txBody>
+      </p:sp>
+      <p:sp>
+        <p:nvSpPr>
+          <p:cNvPr id="18" name="Text 16"/>
+          <p:cNvSpPr/>
+          <p:nvPr/>
+        </p:nvSpPr>
+        <p:spPr>
+          <a:xfrm>
+            <a:off x="5532120" y="2459736"/>
+            <a:ext cx="3108960" cy="228600"/>
+          </a:xfrm>
+          <a:prstGeom prst="rect">
+            <a:avLst/>
+          </a:prstGeom>
+          <a:noFill/>
+          <a:ln/>
+        </p:spPr>
+        <p:txBody>
+          <a:bodyPr wrap="square" lIns="0" tIns="0" rIns="0" bIns="0" rtlCol="0" anchor="ctr"/>
+          <a:lstStyle/>
+          <a:p>
+            <a:pPr marL="0" indent="0">
+              <a:buNone/>
+            </a:pPr>
+            <a:r>
+              <a:rPr lang="en-US" sz="1000" dirty="0">
+                <a:solidFill>
+                  <a:srgbClr val="0D0D0D"/>
+                </a:solidFill>
+                <a:latin typeface="Open Sans" pitchFamily="34" charset="0"/>
+                <a:ea typeface="Open Sans" pitchFamily="34" charset="-122"/>
+                <a:cs typeface="Open Sans" pitchFamily="34" charset="-120"/>
+              </a:rPr>
+              <a:t>Conversion formulas for LIFO, R&amp;D,</a:t>
+            </a:r>
+            <a:endParaRPr lang="en-US" sz="1000" dirty="0"/>
+          </a:p>
+        </p:txBody>
+      </p:sp>
+      <p:sp>
+        <p:nvSpPr>
+          <p:cNvPr id="19" name="Shape 17"/>
+          <p:cNvSpPr/>
+          <p:nvPr/>
+        </p:nvSpPr>
+        <p:spPr>
+          <a:xfrm>
+            <a:off x="5212080" y="2825496"/>
+            <a:ext cx="201168" cy="201168"/>
+          </a:xfrm>
+          <a:prstGeom prst="rect">
+            <a:avLst/>
+          </a:prstGeom>
+          <a:solidFill>
+            <a:srgbClr val="FFFFFF"/>
+          </a:solidFill>
+          <a:ln w="19050">
+            <a:solidFill>
+              <a:srgbClr val="024731"/>
+            </a:solidFill>
+            <a:prstDash val="solid"/>
+          </a:ln>
+        </p:spPr>
+        <p:txBody>
+          <a:bodyPr/>
+          <a:lstStyle/>
+          <a:p>
+            <a:endParaRPr lang="en-US"/>
+          </a:p>
+        </p:txBody>
+      </p:sp>
+      <p:sp>
+        <p:nvSpPr>
+          <p:cNvPr id="20" name="Text 18"/>
+          <p:cNvSpPr/>
+          <p:nvPr/>
+        </p:nvSpPr>
+        <p:spPr>
+          <a:xfrm>
+            <a:off x="5532120" y="2807208"/>
+            <a:ext cx="3108960" cy="228600"/>
+          </a:xfrm>
+          <a:prstGeom prst="rect">
+            <a:avLst/>
+          </a:prstGeom>
+          <a:noFill/>
+          <a:ln/>
+        </p:spPr>
+        <p:txBody>
+          <a:bodyPr wrap="square" lIns="0" tIns="0" rIns="0" bIns="0" rtlCol="0" anchor="ctr"/>
+          <a:lstStyle/>
+          <a:p>
+            <a:pPr marL="0" indent="0">
+              <a:buNone/>
+            </a:pPr>
+            <a:r>
+              <a:rPr lang="en-US" sz="1000" dirty="0">
+                <a:solidFill>
+                  <a:srgbClr val="0D0D0D"/>
+                </a:solidFill>
+                <a:latin typeface="Open Sans" pitchFamily="34" charset="0"/>
+                <a:ea typeface="Open Sans" pitchFamily="34" charset="-122"/>
+                <a:cs typeface="Open Sans" pitchFamily="34" charset="-120"/>
+              </a:rPr>
+              <a:t>leases, impairment, pensions</a:t>
+            </a:r>
+            <a:endParaRPr lang="en-US" sz="1000" dirty="0"/>
+          </a:p>
+        </p:txBody>
+      </p:sp>
+      <p:sp>
+        <p:nvSpPr>
+          <p:cNvPr id="21" name="Shape 19"/>
+          <p:cNvSpPr/>
+          <p:nvPr/>
+        </p:nvSpPr>
+        <p:spPr>
+          <a:xfrm>
+            <a:off x="5212080" y="3172968"/>
+            <a:ext cx="201168" cy="201168"/>
+          </a:xfrm>
+          <a:prstGeom prst="rect">
+            <a:avLst/>
+          </a:prstGeom>
+          <a:solidFill>
+            <a:srgbClr val="FFFFFF"/>
+          </a:solidFill>
+          <a:ln w="19050">
+            <a:solidFill>
+              <a:srgbClr val="024731"/>
+            </a:solidFill>
+            <a:prstDash val="solid"/>
+          </a:ln>
+        </p:spPr>
+        <p:txBody>
+          <a:bodyPr/>
+          <a:lstStyle/>
+          <a:p>
+            <a:endParaRPr lang="en-US"/>
+          </a:p>
+        </p:txBody>
+      </p:sp>
+      <p:sp>
+        <p:nvSpPr>
+          <p:cNvPr id="22" name="Text 20"/>
+          <p:cNvSpPr/>
+          <p:nvPr/>
+        </p:nvSpPr>
+        <p:spPr>
+          <a:xfrm>
+            <a:off x="5532120" y="3154680"/>
+            <a:ext cx="3108960" cy="228600"/>
+          </a:xfrm>
+          <a:prstGeom prst="rect">
+            <a:avLst/>
+          </a:prstGeom>
+          <a:noFill/>
+          <a:ln/>
+        </p:spPr>
+        <p:txBody>
+          <a:bodyPr wrap="square" lIns="0" tIns="0" rIns="0" bIns="0" rtlCol="0" anchor="ctr"/>
+          <a:lstStyle/>
+          <a:p>
+            <a:pPr marL="0" indent="0">
+              <a:buNone/>
+            </a:pPr>
+            <a:r>
+              <a:rPr lang="en-US" sz="1000" dirty="0">
+                <a:solidFill>
+                  <a:srgbClr val="0D0D0D"/>
+                </a:solidFill>
+                <a:latin typeface="Open Sans" pitchFamily="34" charset="0"/>
+                <a:ea typeface="Open Sans" pitchFamily="34" charset="-122"/>
+                <a:cs typeface="Open Sans" pitchFamily="34" charset="-120"/>
+              </a:rPr>
+              <a:t>Global convergence status table</a:t>
+            </a:r>
+            <a:endParaRPr lang="en-US" sz="1000" dirty="0"/>
+          </a:p>
+        </p:txBody>
+      </p:sp>
+      <p:sp>
+        <p:nvSpPr>
+          <p:cNvPr id="23" name="Shape 21"/>
+          <p:cNvSpPr/>
+          <p:nvPr/>
+        </p:nvSpPr>
+        <p:spPr>
+          <a:xfrm>
+            <a:off x="5212080" y="3520440"/>
+            <a:ext cx="201168" cy="201168"/>
+          </a:xfrm>
+          <a:prstGeom prst="rect">
+            <a:avLst/>
+          </a:prstGeom>
+          <a:solidFill>
+            <a:srgbClr val="FFFFFF"/>
+          </a:solidFill>
+          <a:ln w="19050">
+            <a:solidFill>
+              <a:srgbClr val="024731"/>
+            </a:solidFill>
+            <a:prstDash val="solid"/>
+          </a:ln>
+        </p:spPr>
+        <p:txBody>
+          <a:bodyPr/>
+          <a:lstStyle/>
+          <a:p>
+            <a:endParaRPr lang="en-US"/>
+          </a:p>
+        </p:txBody>
+      </p:sp>
+      <p:sp>
+        <p:nvSpPr>
+          <p:cNvPr id="24" name="Text 22"/>
+          <p:cNvSpPr/>
+          <p:nvPr/>
+        </p:nvSpPr>
+        <p:spPr>
+          <a:xfrm>
+            <a:off x="5532120" y="3502152"/>
+            <a:ext cx="3108960" cy="228600"/>
+          </a:xfrm>
+          <a:prstGeom prst="rect">
+            <a:avLst/>
+          </a:prstGeom>
+          <a:noFill/>
+          <a:ln/>
+        </p:spPr>
+        <p:txBody>
+          <a:bodyPr wrap="square" lIns="0" tIns="0" rIns="0" bIns="0" rtlCol="0" anchor="ctr"/>
+          <a:lstStyle/>
+          <a:p>
+            <a:pPr marL="0" indent="0">
+              <a:buNone/>
+            </a:pPr>
+            <a:r>
+              <a:rPr lang="en-US" sz="1000" dirty="0">
+                <a:solidFill>
+                  <a:srgbClr val="0D0D0D"/>
+                </a:solidFill>
+                <a:latin typeface="Open Sans" pitchFamily="34" charset="0"/>
+                <a:ea typeface="Open Sans" pitchFamily="34" charset="-122"/>
+                <a:cs typeface="Open Sans" pitchFamily="34" charset="-120"/>
+              </a:rPr>
+              <a:t>docs/decisions/2026-05-24-...-framework.md</a:t>
+            </a:r>
+            <a:endParaRPr lang="en-US" sz="1000" dirty="0"/>
+          </a:p>
+        </p:txBody>
+      </p:sp>
+      <p:sp>
+        <p:nvSpPr>
+          <p:cNvPr id="29" name="Shape 27"/>
+          <p:cNvSpPr/>
+          <p:nvPr/>
+        </p:nvSpPr>
+        <p:spPr>
+          <a:xfrm>
+            <a:off x="548640" y="4434840"/>
+            <a:ext cx="4114800" cy="457200"/>
+          </a:xfrm>
+          <a:prstGeom prst="rect">
+            <a:avLst/>
+          </a:prstGeom>
+          <a:solidFill>
+            <a:srgbClr val="024731"/>
+          </a:solidFill>
+          <a:ln/>
+        </p:spPr>
+        <p:txBody>
+          <a:bodyPr/>
+          <a:lstStyle/>
+          <a:p>
+            <a:endParaRPr lang="en-US"/>
+          </a:p>
+        </p:txBody>
+      </p:sp>
+      <p:sp>
+        <p:nvSpPr>
+          <p:cNvPr id="30" name="Text 28"/>
+          <p:cNvSpPr/>
+          <p:nvPr/>
+        </p:nvSpPr>
+        <p:spPr>
+          <a:xfrm>
+            <a:off x="685800" y="4453128"/>
+            <a:ext cx="3840480" cy="411480"/>
+          </a:xfrm>
+          <a:prstGeom prst="rect">
+            <a:avLst/>
+          </a:prstGeom>
+          <a:noFill/>
+          <a:ln/>
+        </p:spPr>
+        <p:txBody>
+          <a:bodyPr wrap="square" rtlCol="0" anchor="ctr"/>
+          <a:lstStyle/>
+          <a:p>
+            <a:pPr marL="0" indent="0">
+              <a:buNone/>
+            </a:pPr>
+            <a:r>
+              <a:rPr lang="en-US" sz="1000" dirty="0">
+                <a:solidFill>
+                  <a:srgbClr val="FFFFFF"/>
+                </a:solidFill>
+                <a:latin typeface="Open Sans" pitchFamily="34" charset="0"/>
+                <a:ea typeface="Open Sans" pitchFamily="34" charset="-122"/>
+                <a:cs typeface="Open Sans" pitchFamily="34" charset="-120"/>
+              </a:rPr>
+              <a:t>Start with the quick-reference. Use the GAAP Bridge template in your workbook. Read the full memo only if you want the deep background.</a:t>
+            </a:r>
+            <a:endParaRPr lang="en-US" sz="1000" dirty="0"/>
+          </a:p>
+        </p:txBody>
+      </p:sp>
+    </p:spTree>
+  </p:cSld>
+  <p:clrMapOvr>
+    <a:masterClrMapping/>
+  </p:clrMapOvr>
+</p:sld>
+</file>
+
 <file path=ppt/slides/slide6.xml><?xml version="1.0" encoding="utf-8"?>
 <p:sld xmlns:a="http://schemas.openxmlformats.org/drawingml/2006/main" xmlns:r="http://schemas.openxmlformats.org/officeDocument/2006/relationships" xmlns:p="http://schemas.openxmlformats.org/presentationml/2006/main">
   <p:cSld>
@@ -45295,7 +48494,7 @@
                 <a:ea typeface="Open Sans" pitchFamily="34" charset="-122"/>
                 <a:cs typeface="Open Sans" pitchFamily="34" charset="-120"/>
               </a:rPr>
-              <a:t>GitHub is a cloud platform for version control. Think of it as Google Docs or </a:t>
+              <a:t xml:space="preserve">GitHub is a cloud platform for version control. Think of it as Google Docs or </a:t>
             </a:r>
             <a:r>
               <a:rPr lang="en-US" sz="1300" dirty="0" err="1">
@@ -45317,7 +48516,7 @@
                 <a:ea typeface="Open Sans" pitchFamily="34" charset="-122"/>
                 <a:cs typeface="Open Sans" pitchFamily="34" charset="-120"/>
               </a:rPr>
-              <a:t> for code and documents — every change is tracked, reversible, and visible to your instructor.</a:t>
+              <a:t xml:space="preserve"> for code and documents — every change is tracked, reversible, and visible to your instructor.</a:t>
             </a:r>
             <a:endParaRPr lang="en-US" sz="1300" dirty="0"/>
           </a:p>

</xml_diff>